<commit_message>
docs(presentation): update presentation to v2.4 with Tri-Engine architecture, spec-driven UVM synthesis & scaled test plan
</commit_message>
<xml_diff>
--- a/VeriSight_Investor_Presentation.pptx
+++ b/VeriSight_Investor_Presentation.pptx
@@ -27,6 +27,7 @@
     <p:sldId id="275" r:id="rId26"/>
     <p:sldId id="276" r:id="rId27"/>
     <p:sldId id="277" r:id="rId28"/>
+    <p:sldId id="278" r:id="rId29"/>
   </p:sldIdLst>
   <p:sldSz cx="12191695" cy="6858000" type="screen4x3"/>
   <p:notesSz cx="6858000" cy="9144000"/>
@@ -3184,7 +3185,7 @@
                 </a:solidFill>
                 <a:latin typeface="Arial"/>
               </a:rPr>
-              <a:t>Autonomous Silicon Verification &amp; Failure Debugging Copilot</a:t>
+              <a:t>Autonomous Silicon Verification, Plan Synthesis &amp; Failure Debugging Copilot</a:t>
             </a:r>
           </a:p>
           <a:p>
@@ -3195,8 +3196,8 @@
                 </a:solidFill>
                 <a:latin typeface="Arial"/>
               </a:rPr>
-              <a:t>Bridging Natural Language Hardware Specifications to Zero-Bug Silicon with Multi-Agent AI,
-Closed-Loop Simulation, Deterministic Root Cause Analysis, and Automated Patch Generation.</a:t>
+              <a:t>Bridging Natural Language Hardware Specifications to Zero-Bug Silicon with Tri-Engine Multi-Agent AI,
+Spec-Driven UVM Testbench Synthesis, Closed-Loop Simulation, and Deterministic Root Cause Analysis.</a:t>
             </a:r>
           </a:p>
         </p:txBody>
@@ -6442,7 +6443,7 @@
                 </a:solidFill>
                 <a:latin typeface="Arial"/>
               </a:rPr>
-              <a:t>Topic 9: Dashboard Overview — The 6 Autonomous Workflows</a:t>
+              <a:t>Topic 9: Platform Capabilities — The Tri-Engine Architecture &amp; Guided Launcher</a:t>
             </a:r>
           </a:p>
         </p:txBody>
@@ -6520,7 +6521,7 @@
                   <a:srgbClr val="0B4D32"/>
                 </a:solidFill>
               </a:rPr>
-              <a:t>Complete Suite: 6 Autonomous Workflows
+              <a:t>The Tri-Engine Autonomous Verification Suite
 </a:t>
             </a:r>
           </a:p>
@@ -6531,7 +6532,7 @@
                   <a:srgbClr val="0F172A"/>
                 </a:solidFill>
               </a:rPr>
-              <a:t>• [1] VeriSight Debug: </a:t>
+              <a:t>• Engine 1: VeriSight Debug: </a:t>
             </a:r>
             <a:r>
               <a:rPr sz="950">
@@ -6539,7 +6540,7 @@
                   <a:srgbClr val="334155"/>
                 </a:solidFill>
               </a:rPr>
-              <a:t>Root-cause analysis, 9-rule triage, pyslang AST trace, and automated patch synthesis.
+              <a:t>Autonomous RCA, 9 deterministic rules, pyslang AST fan-in cone tracing, multi-clock CDC analysis, zero-touch unified git patch synthesis &amp; sandbox validation.
 </a:t>
             </a:r>
           </a:p>
@@ -6550,7 +6551,7 @@
                   <a:srgbClr val="0F172A"/>
                 </a:solidFill>
               </a:rPr>
-              <a:t>• [2] VeriSight Plan: </a:t>
+              <a:t>• Engine 2: VeriSight Plan: </a:t>
             </a:r>
             <a:r>
               <a:rPr sz="950">
@@ -6558,7 +6559,7 @@
                   <a:srgbClr val="334155"/>
                 </a:solidFill>
               </a:rPr>
-              <a:t>Extracts features, test matrices, covergroups, and SVA assertions directly from specs.
+              <a:t>Autonomous Verification Plan, feature decomposition, 50+ scaled testcases across 8 categories, 90+ coverage points, 150+ bins, 30+ SVA assertions. Pure spec-driven execution from PDF/MD with optional RTL.
 </a:t>
             </a:r>
           </a:p>
@@ -6569,7 +6570,7 @@
                   <a:srgbClr val="0F172A"/>
                 </a:solidFill>
               </a:rPr>
-              <a:t>• [3] Closed-Loop Sim: </a:t>
+              <a:t>• Engine 3: VeriSight TestBench: </a:t>
             </a:r>
             <a:r>
               <a:rPr sz="950">
@@ -6577,7 +6578,7 @@
                   <a:srgbClr val="334155"/>
                 </a:solidFill>
               </a:rPr>
-              <a:t>Zero-touch runner (iverilog/verilator/vcs) with error interception and auto-triage.
+              <a:t>Spec-Driven UVM 1.2 synthesis grounded in specification as sole functional truth. Behavioral reference models and scoreboards independently isolate DUT bugs without mirroring RTL flaws (14 VIP files).
 </a:t>
             </a:r>
           </a:p>
@@ -6588,7 +6589,7 @@
                   <a:srgbClr val="0F172A"/>
                 </a:solidFill>
               </a:rPr>
-              <a:t>• [4] Live Web Cockpit: </a:t>
+              <a:t>• Live Web Cockpit (`./start serve`): </a:t>
             </a:r>
             <a:r>
               <a:rPr sz="950">
@@ -6596,7 +6597,7 @@
                   <a:srgbClr val="334155"/>
                 </a:solidFill>
               </a:rPr>
-              <a:t>Interactive browser GUI with Live Coverage Cockpit, Waveform Studio &amp; RCA Inspector.
+              <a:t>Modern browser GUI with Sage/Burgundy styling, live coverage progress tracking, and interactive sub-cycle waveform inspection.
 </a:t>
             </a:r>
           </a:p>
@@ -6607,7 +6608,7 @@
                   <a:srgbClr val="0F172A"/>
                 </a:solidFill>
               </a:rPr>
-              <a:t>• [5] Quick Demos: </a:t>
+              <a:t>• Cloud EDA Exporter (`./start edaplayground`): </a:t>
             </a:r>
             <a:r>
               <a:rPr sz="950">
@@ -6615,26 +6616,7 @@
                   <a:srgbClr val="334155"/>
                 </a:solidFill>
               </a:rPr>
-              <a:t>1-click instant evaluations on pre-packaged ALU, FIFO, and AXI4-Stream testbeds.
-</a:t>
-            </a:r>
-          </a:p>
-          <a:p>
-            <a:r>
-              <a:rPr b="1" sz="1000">
-                <a:solidFill>
-                  <a:srgbClr val="0F172A"/>
-                </a:solidFill>
-              </a:rPr>
-              <a:t>• [6] Advanced CLI Exit: </a:t>
-            </a:r>
-            <a:r>
-              <a:rPr sz="950">
-                <a:solidFill>
-                  <a:srgbClr val="334155"/>
-                </a:solidFill>
-              </a:rPr>
-              <a:t>Headless scriptable invocation for nightly CI/CD regression farms and pipelines.
+              <a:t>1-click export of complete synthesized testbenches and RTL packages to cloud simulators for instant stakeholder sharing.
 </a:t>
             </a:r>
           </a:p>
@@ -7069,7 +7051,7 @@
                 </a:solidFill>
                 <a:latin typeface="Arial"/>
               </a:rPr>
-              <a:t>COVERAGE CLOSURE  •  </a:t>
+              <a:t>SPEC-DRIVEN TB  •  </a:t>
             </a:r>
             <a:r>
               <a:rPr sz="2100" b="1">
@@ -7078,7 +7060,7 @@
                 </a:solidFill>
                 <a:latin typeface="Arial"/>
               </a:rPr>
-              <a:t>Topic 9 (Cont.): Live Coverage Cockpit — Planned vs. Actual UCDB</a:t>
+              <a:t>Topic 9 (Cont.): VeriSight TestBench — Spec-Driven UVM 1.2 Synthesis</a:t>
             </a:r>
           </a:p>
         </p:txBody>
@@ -7092,7 +7074,7 @@
         <p:spPr>
           <a:xfrm>
             <a:off x="731520" y="1371600"/>
-            <a:ext cx="5029200" cy="4846320"/>
+            <a:ext cx="5120640" cy="4846320"/>
           </a:xfrm>
           <a:prstGeom prst="roundRect">
             <a:avLst/>
@@ -7130,7 +7112,7 @@
       </p:sp>
       <p:pic>
         <p:nvPicPr>
-          <p:cNvPr id="5" name="Picture 4" descr="gif_02_coverage_closure.gif"/>
+          <p:cNvPr id="5" name="Picture 4" descr="screenshot_16_spec_driven_tb.png"/>
           <p:cNvPicPr>
             <a:picLocks noChangeAspect="1"/>
           </p:cNvPicPr>
@@ -7145,7 +7127,7 @@
         <p:spPr>
           <a:xfrm>
             <a:off x="822960" y="1508760"/>
-            <a:ext cx="4846320" cy="3931920"/>
+            <a:ext cx="4937760" cy="3931920"/>
           </a:xfrm>
           <a:prstGeom prst="rect">
             <a:avLst/>
@@ -7161,7 +7143,7 @@
         <p:spPr>
           <a:xfrm>
             <a:off x="822960" y="5532120"/>
-            <a:ext cx="4846320" cy="548640"/>
+            <a:ext cx="4937760" cy="548640"/>
           </a:xfrm>
           <a:prstGeom prst="rect">
             <a:avLst/>
@@ -7180,7 +7162,7 @@
                   <a:srgbClr val="64748B"/>
                 </a:solidFill>
               </a:rPr>
-              <a:t>Animated Dynamic Coverage Closure Progression (42% -&gt; 100%)</a:t>
+              <a:t>Spec-Driven Verification Scoreboard &amp; Synthesized 14-Component UVM VIP Suite</a:t>
             </a:r>
           </a:p>
         </p:txBody>
@@ -7193,8 +7175,8 @@
         </p:nvSpPr>
         <p:spPr>
           <a:xfrm>
-            <a:off x="5943600" y="1371600"/>
-            <a:ext cx="5486400" cy="4846320"/>
+            <a:off x="6035040" y="1371600"/>
+            <a:ext cx="5394960" cy="4846320"/>
           </a:xfrm>
           <a:prstGeom prst="roundRect">
             <a:avLst/>
@@ -7238,8 +7220,8 @@
         </p:nvSpPr>
         <p:spPr>
           <a:xfrm>
-            <a:off x="6126480" y="1508760"/>
-            <a:ext cx="5120640" cy="4572000"/>
+            <a:off x="6217920" y="1508760"/>
+            <a:ext cx="5029200" cy="4572000"/>
           </a:xfrm>
           <a:prstGeom prst="rect">
             <a:avLst/>
@@ -7258,7 +7240,7 @@
                   <a:srgbClr val="0B4D32"/>
                 </a:solidFill>
               </a:rPr>
-              <a:t>Dynamic Coverage Cockpit &amp; Planner Features
+              <a:t>Spec-Driven UVM 1.2 Synthesis Engine
 </a:t>
             </a:r>
           </a:p>
@@ -7269,15 +7251,16 @@
                   <a:srgbClr val="0F172A"/>
                 </a:solidFill>
               </a:rPr>
-              <a:t>• Ingests Live Simulator UCDB / vDB: </a:t>
-            </a:r>
-            <a:r>
-              <a:rPr sz="1000">
+              <a:t>• The 'Spec-as-Truth' Principle:
+</a:t>
+            </a:r>
+            <a:r>
+              <a:rPr sz="950">
                 <a:solidFill>
                   <a:srgbClr val="334155"/>
                 </a:solidFill>
               </a:rPr>
-              <a:t>Parses Synopsys vDB and Questa UCDB databases to compare actual coverage against planned features in real-time.
+              <a:t>Traditional AI testbenches mirror RTL behavior, concealing design bugs. VeriSight treats the Architectural Specification as the sole functional truth. Golden reference models and scoreboards independently isolate RTL defects rather than reproducing them.
 </a:t>
             </a:r>
           </a:p>
@@ -7288,15 +7271,16 @@
                   <a:srgbClr val="0F172A"/>
                 </a:solidFill>
               </a:rPr>
-              <a:t>• Visual Progress by Feature: </a:t>
-            </a:r>
-            <a:r>
-              <a:rPr sz="1000">
+              <a:t>• 10-Stage Reasoning Pipeline:
+</a:t>
+            </a:r>
+            <a:r>
+              <a:rPr sz="950">
                 <a:solidFill>
                   <a:srgbClr val="334155"/>
                 </a:solidFill>
               </a:rPr>
-              <a:t>Every architectural feature has a dedicated progress bar showing percentage hit vs 100% target.
+              <a:t>Spec Ingestion (PDF/MD) -&gt; Port &amp; Protocol Extraction -&gt; Transaction Item Definition -&gt; VIP Components -&gt; Behavioral Golden Reference Model -&gt; Scoreboard Comparator -&gt; Coverage Subscriber -&gt; Top-Level Testbench Module.
 </a:t>
             </a:r>
           </a:p>
@@ -7307,15 +7291,16 @@
                   <a:srgbClr val="0F172A"/>
                 </a:solidFill>
               </a:rPr>
-              <a:t>• Red Highlighted Unhit Bins: </a:t>
-            </a:r>
-            <a:r>
-              <a:rPr sz="1000">
+              <a:t>• Complete 14-Component UVM VIP Suite:
+</a:t>
+            </a:r>
+            <a:r>
+              <a:rPr sz="950">
                 <a:solidFill>
                   <a:srgbClr val="334155"/>
                 </a:solidFill>
               </a:rPr>
-              <a:t>Zero-hit bins (e.g. rare FIFO backpressure corner cases) are highlighted in red with direct drill-down.
+              <a:t>Generates `_if.sv`, `_seq_item.sv`, `_sequencer.sv`, `_driver.sv`, `_monitor.sv`, `_agent.sv`, `_reference_model.sv`, `_scoreboard.sv`, `_coverage.sv`, `_sequence.sv`, `_env.sv`, `_test.sv`, `_pkg.sv`, and `_tb_top.sv`.
 </a:t>
             </a:r>
           </a:p>
@@ -7326,34 +7311,16 @@
                   <a:srgbClr val="0F172A"/>
                 </a:solidFill>
               </a:rPr>
-              <a:t>• 1-Click AI Directed Stimulus: </a:t>
-            </a:r>
-            <a:r>
-              <a:rPr sz="1000">
+              <a:t>• Static IEEE-1800 &amp; Sandbox Pre-Check:
+</a:t>
+            </a:r>
+            <a:r>
+              <a:rPr sz="950">
                 <a:solidFill>
                   <a:srgbClr val="334155"/>
                 </a:solidFill>
               </a:rPr>
-              <a:t>Engineers click 'Generate Directed Sequence' to automatically synthesize constrained-random sequences targeting unhit bins.
-</a:t>
-            </a:r>
-          </a:p>
-          <a:p>
-            <a:r>
-              <a:rPr b="1" sz="1050">
-                <a:solidFill>
-                  <a:srgbClr val="0F172A"/>
-                </a:solidFill>
-              </a:rPr>
-              <a:t>• ISO 26262 / DO-254 Compliance: </a:t>
-            </a:r>
-            <a:r>
-              <a:rPr sz="1000">
-                <a:solidFill>
-                  <a:srgbClr val="334155"/>
-                </a:solidFill>
-              </a:rPr>
-              <a:t>Automatically exports requirement-to-test bi-directional traceability matrix (traceability_matrix.csv).
+              <a:t>Pre-validated with `pyslang` parser before delivery; guaranteed syntax validity, UVM 1.2 compliance, and zero warnings on VCS, Questa, and Xcelium.
 </a:t>
             </a:r>
           </a:p>
@@ -7686,7 +7653,7 @@
                 </a:solidFill>
                 <a:latin typeface="Arial"/>
               </a:rPr>
-              <a:t>GUI DIAGNOSTIC  •  </a:t>
+              <a:t>PLAN ARCHITECT  •  </a:t>
             </a:r>
             <a:r>
               <a:rPr sz="2100" b="1">
@@ -7695,7 +7662,7 @@
                 </a:solidFill>
                 <a:latin typeface="Arial"/>
               </a:rPr>
-              <a:t>Topic 9 (Cont.): Root-Cause Studio &amp; Waveform Inspector</a:t>
+              <a:t>Topic 9 (Cont.): Dynamic Coverage Closure &amp; 50+ Test Scaling — VeriSight Plan</a:t>
             </a:r>
           </a:p>
         </p:txBody>
@@ -7709,7 +7676,7 @@
         <p:spPr>
           <a:xfrm>
             <a:off x="731520" y="1371600"/>
-            <a:ext cx="5669280" cy="4846320"/>
+            <a:ext cx="5029200" cy="4846320"/>
           </a:xfrm>
           <a:prstGeom prst="roundRect">
             <a:avLst/>
@@ -7747,7 +7714,7 @@
       </p:sp>
       <p:pic>
         <p:nvPicPr>
-          <p:cNvPr id="5" name="Picture 4" descr="screenshot_12_rca_dashboard_gui.png"/>
+          <p:cNvPr id="5" name="Picture 4" descr="gif_02_coverage_closure.gif"/>
           <p:cNvPicPr>
             <a:picLocks noChangeAspect="1"/>
           </p:cNvPicPr>
@@ -7762,7 +7729,7 @@
         <p:spPr>
           <a:xfrm>
             <a:off x="822960" y="1508760"/>
-            <a:ext cx="5486400" cy="3931920"/>
+            <a:ext cx="4846320" cy="3931920"/>
           </a:xfrm>
           <a:prstGeom prst="rect">
             <a:avLst/>
@@ -7778,7 +7745,7 @@
         <p:spPr>
           <a:xfrm>
             <a:off x="822960" y="5532120"/>
-            <a:ext cx="5486400" cy="548640"/>
+            <a:ext cx="4846320" cy="548640"/>
           </a:xfrm>
           <a:prstGeom prst="rect">
             <a:avLst/>
@@ -7797,7 +7764,7 @@
                   <a:srgbClr val="64748B"/>
                 </a:solidFill>
               </a:rPr>
-              <a:t>Interactive RCA Dashboard &amp; Waveform Studio with Cursor Synchronization</a:t>
+              <a:t>Animated Dynamic Coverage Closure Progression (42% -&gt; 100%)</a:t>
             </a:r>
           </a:p>
         </p:txBody>
@@ -7810,8 +7777,8 @@
         </p:nvSpPr>
         <p:spPr>
           <a:xfrm>
-            <a:off x="6583680" y="1371600"/>
-            <a:ext cx="4846320" cy="4846320"/>
+            <a:off x="5943600" y="1371600"/>
+            <a:ext cx="5486400" cy="4846320"/>
           </a:xfrm>
           <a:prstGeom prst="roundRect">
             <a:avLst/>
@@ -7855,8 +7822,8 @@
         </p:nvSpPr>
         <p:spPr>
           <a:xfrm>
-            <a:off x="6766560" y="1508760"/>
-            <a:ext cx="4480560" cy="4572000"/>
+            <a:off x="6126480" y="1508760"/>
+            <a:ext cx="5120640" cy="4572000"/>
           </a:xfrm>
           <a:prstGeom prst="rect">
             <a:avLst/>
@@ -7875,7 +7842,7 @@
                   <a:srgbClr val="0B4D32"/>
                 </a:solidFill>
               </a:rPr>
-              <a:t>Sub-Cycle Waveform Correlation Features
+              <a:t>Scaled Verification Plan &amp; Pure Spec-Driven Execution
 </a:t>
             </a:r>
           </a:p>
@@ -7886,16 +7853,34 @@
                   <a:srgbClr val="0F172A"/>
                 </a:solidFill>
               </a:rPr>
-              <a:t>• Unified Failure Timeline:
+              <a:t>• Pure Spec-Driven Mode (Optional RTL): </a:t>
+            </a:r>
+            <a:r>
+              <a:rPr sz="950">
+                <a:solidFill>
+                  <a:srgbClr val="334155"/>
+                </a:solidFill>
+              </a:rPr>
+              <a:t>Ingests architectural datasheets (PDF, Markdown, text). RTL is optional — eliminating default fallback hallucinations and enabling shift-left pre-RTL verification planning directly from specs.
 </a:t>
             </a:r>
+          </a:p>
+          <a:p>
+            <a:r>
+              <a:rPr b="1" sz="1050">
+                <a:solidFill>
+                  <a:srgbClr val="0F172A"/>
+                </a:solidFill>
+              </a:rPr>
+              <a:t>• 50+ Scaled Tests across 8 Categories: </a:t>
+            </a:r>
             <a:r>
               <a:rPr sz="950">
                 <a:solidFill>
                   <a:srgbClr val="334155"/>
                 </a:solidFill>
               </a:rPr>
-              <a:t>Correlates simulation log errors with exact physical clock edges and transaction markers.
+              <a:t>Synthesizes Directed, Constrained-Random, Reset/Init, Boundary/Corner, Error/Negative, Performance/Backpressure, Concurrency, and Protocol-Specific test scenarios.
 </a:t>
             </a:r>
           </a:p>
@@ -7906,16 +7891,34 @@
                   <a:srgbClr val="0F172A"/>
                 </a:solidFill>
               </a:rPr>
-              <a:t>• Multi-Signal Bus Radix View:
+              <a:t>• Multi-Covergroups with 90+ CPs &amp; 150+ Bins: </a:t>
+            </a:r>
+            <a:r>
+              <a:rPr sz="950">
+                <a:solidFill>
+                  <a:srgbClr val="334155"/>
+                </a:solidFill>
+              </a:rPr>
+              <a:t>Defines protocol state transitions, illegal state avoidance, cross-coverage matrices, and FIFO/bus boundary conditions.
 </a:t>
             </a:r>
+          </a:p>
+          <a:p>
+            <a:r>
+              <a:rPr b="1" sz="1050">
+                <a:solidFill>
+                  <a:srgbClr val="0F172A"/>
+                </a:solidFill>
+              </a:rPr>
+              <a:t>• 30+ SystemVerilog Assertions (SVA): </a:t>
+            </a:r>
             <a:r>
               <a:rPr sz="950">
                 <a:solidFill>
                   <a:srgbClr val="334155"/>
                 </a:solidFill>
               </a:rPr>
-              <a:t>Decodes binary, hexadecimal, and one-hot FSM states dynamically in browser canvas.
+              <a:t>Synthesizes formal protocol timing checks, handshake assertions, and safety properties directly from specification requirements.
 </a:t>
             </a:r>
           </a:p>
@@ -7926,8 +7929,7 @@
                   <a:srgbClr val="0F172A"/>
                 </a:solidFill>
               </a:rPr>
-              <a:t>• Failure Marker Cursor:
-</a:t>
+              <a:t>• Simulator UCDB Ingestion &amp; ISO 26262 Matrix: </a:t>
             </a:r>
             <a:r>
               <a:rPr sz="950">
@@ -7935,27 +7937,7 @@
                   <a:srgbClr val="334155"/>
                 </a:solidFill>
               </a:rPr>
-              <a:t>Automatically places inspection cursor at exact assertion trip timestamp (e.g. 450ns).
-</a:t>
-            </a:r>
-          </a:p>
-          <a:p>
-            <a:r>
-              <a:rPr b="1" sz="1050">
-                <a:solidFill>
-                  <a:srgbClr val="0F172A"/>
-                </a:solidFill>
-              </a:rPr>
-              <a:t>• pyslang Fan-In Cone Tracing:
-</a:t>
-            </a:r>
-            <a:r>
-              <a:rPr sz="950">
-                <a:solidFill>
-                  <a:srgbClr val="334155"/>
-                </a:solidFill>
-              </a:rPr>
-              <a:t>Cross-probes failing signals backward to active drivers, uninitialized registers, and clock boundaries.
+              <a:t>Ingests Questa UCDB / Synopsys vDB to identify zero-hit holes and outputs bi-directional traceability matrices (`traceability_matrix.csv`).
 </a:t>
             </a:r>
           </a:p>
@@ -8288,7 +8270,7 @@
                 </a:solidFill>
                 <a:latin typeface="Arial"/>
               </a:rPr>
-              <a:t>AUTOMATED REPAIR  •  </a:t>
+              <a:t>GUI DIAGNOSTIC  •  </a:t>
             </a:r>
             <a:r>
               <a:rPr sz="2100" b="1">
@@ -8297,7 +8279,7 @@
                 </a:solidFill>
                 <a:latin typeface="Arial"/>
               </a:rPr>
-              <a:t>Topic 9 (Cont.): Automated Unified Patching &amp; Sandbox Safety</a:t>
+              <a:t>Topic 9 (Cont.): Root-Cause Studio &amp; Waveform Inspector</a:t>
             </a:r>
           </a:p>
         </p:txBody>
@@ -8349,7 +8331,7 @@
       </p:sp>
       <p:pic>
         <p:nvPicPr>
-          <p:cNvPr id="5" name="Picture 4" descr="screenshot_13_automated_patch.png"/>
+          <p:cNvPr id="5" name="Picture 4" descr="screenshot_12_rca_dashboard_gui.png"/>
           <p:cNvPicPr>
             <a:picLocks noChangeAspect="1"/>
           </p:cNvPicPr>
@@ -8399,7 +8381,7 @@
                   <a:srgbClr val="64748B"/>
                 </a:solidFill>
               </a:rPr>
-              <a:t>VeriSight Unified Git Diff Patch with Automated Sandbox Verification</a:t>
+              <a:t>Interactive RCA Dashboard &amp; Waveform Studio with Cursor Synchronization</a:t>
             </a:r>
           </a:p>
         </p:txBody>
@@ -8477,7 +8459,7 @@
                   <a:srgbClr val="0B4D32"/>
                 </a:solidFill>
               </a:rPr>
-              <a:t>The Zero-Touch Repair Loop
+              <a:t>Sub-Cycle Waveform Correlation Features
 </a:t>
             </a:r>
           </a:p>
@@ -8488,7 +8470,7 @@
                   <a:srgbClr val="0F172A"/>
                 </a:solidFill>
               </a:rPr>
-              <a:t>1. Minimal Git Diff
+              <a:t>• Unified Failure Timeline:
 </a:t>
             </a:r>
             <a:r>
@@ -8497,7 +8479,7 @@
                   <a:srgbClr val="334155"/>
                 </a:solidFill>
               </a:rPr>
-              <a:t>Synthesizes surgical diff altering only the root-cause bug line without unintended side effects.
+              <a:t>Correlates simulation log errors with exact physical clock edges and transaction markers.
 </a:t>
             </a:r>
           </a:p>
@@ -8508,7 +8490,7 @@
                   <a:srgbClr val="0F172A"/>
                 </a:solidFill>
               </a:rPr>
-              <a:t>2. AST Syntax Pre-Check
+              <a:t>• Multi-Signal Bus Radix View:
 </a:t>
             </a:r>
             <a:r>
@@ -8517,7 +8499,7 @@
                   <a:srgbClr val="334155"/>
                 </a:solidFill>
               </a:rPr>
-              <a:t>Parses modified HDL with pyslang (Slang frontend) to catch genuine syntax errors before saving — distinguishing syntax errors from missing macros.
+              <a:t>Decodes binary, hexadecimal, and one-hot FSM states dynamically in browser canvas.
 </a:t>
             </a:r>
           </a:p>
@@ -8528,7 +8510,7 @@
                   <a:srgbClr val="0F172A"/>
                 </a:solidFill>
               </a:rPr>
-              <a:t>3. Isolated Sandbox Simulation
+              <a:t>• Failure Marker Cursor:
 </a:t>
             </a:r>
             <a:r>
@@ -8537,7 +8519,7 @@
                   <a:srgbClr val="334155"/>
                 </a:solidFill>
               </a:rPr>
-              <a:t>Copies patched design into /tmp sandbox and re-executes original simulation using the active EDA tool.
+              <a:t>Automatically places inspection cursor at exact assertion trip timestamp (e.g. 450ns).
 </a:t>
             </a:r>
           </a:p>
@@ -8548,7 +8530,7 @@
                   <a:srgbClr val="0F172A"/>
                 </a:solidFill>
               </a:rPr>
-              <a:t>4. Regression Clean Sign-Off
+              <a:t>• pyslang Fan-In Cone Tracing:
 </a:t>
             </a:r>
             <a:r>
@@ -8557,7 +8539,7 @@
                   <a:srgbClr val="334155"/>
                 </a:solidFill>
               </a:rPr>
-              <a:t>Confirms failing assertion is eliminated and all existing regression tests continue to pass.
+              <a:t>Cross-probes failing signals backward to active drivers, uninitialized registers, and clock boundaries.
 </a:t>
             </a:r>
           </a:p>
@@ -8890,7 +8872,7 @@
                 </a:solidFill>
                 <a:latin typeface="Arial"/>
               </a:rPr>
-              <a:t>COST EFFICIENCY  •  </a:t>
+              <a:t>AUTOMATED REPAIR  •  </a:t>
             </a:r>
             <a:r>
               <a:rPr sz="2100" b="1">
@@ -8899,7 +8881,7 @@
                 </a:solidFill>
                 <a:latin typeface="Arial"/>
               </a:rPr>
-              <a:t>Topic 10: Token Utilization Over Cost — Sovereign Economics</a:t>
+              <a:t>Topic 9 (Cont.): Automated Unified Patching &amp; Sandbox Safety</a:t>
             </a:r>
           </a:p>
         </p:txBody>
@@ -8913,7 +8895,109 @@
         <p:spPr>
           <a:xfrm>
             <a:off x="731520" y="1371600"/>
-            <a:ext cx="3429000" cy="4846320"/>
+            <a:ext cx="5669280" cy="4846320"/>
+          </a:xfrm>
+          <a:prstGeom prst="roundRect">
+            <a:avLst/>
+          </a:prstGeom>
+          <a:solidFill>
+            <a:srgbClr val="FFFFFF"/>
+          </a:solidFill>
+          <a:ln w="12700">
+            <a:solidFill>
+              <a:srgbClr val="CBD5E1"/>
+            </a:solidFill>
+          </a:ln>
+        </p:spPr>
+        <p:style>
+          <a:lnRef idx="1">
+            <a:schemeClr val="accent1"/>
+          </a:lnRef>
+          <a:fillRef idx="3">
+            <a:schemeClr val="accent1"/>
+          </a:fillRef>
+          <a:effectRef idx="2">
+            <a:schemeClr val="accent1"/>
+          </a:effectRef>
+          <a:fontRef idx="minor">
+            <a:schemeClr val="lt1"/>
+          </a:fontRef>
+        </p:style>
+        <p:txBody>
+          <a:bodyPr rtlCol="0" anchor="ctr"/>
+          <a:lstStyle/>
+          <a:p>
+            <a:pPr algn="ctr"/>
+          </a:p>
+        </p:txBody>
+      </p:sp>
+      <p:pic>
+        <p:nvPicPr>
+          <p:cNvPr id="5" name="Picture 4" descr="screenshot_13_automated_patch.png"/>
+          <p:cNvPicPr>
+            <a:picLocks noChangeAspect="1"/>
+          </p:cNvPicPr>
+          <p:nvPr/>
+        </p:nvPicPr>
+        <p:blipFill>
+          <a:blip r:embed="rId3"/>
+          <a:stretch>
+            <a:fillRect/>
+          </a:stretch>
+        </p:blipFill>
+        <p:spPr>
+          <a:xfrm>
+            <a:off x="822960" y="1508760"/>
+            <a:ext cx="5486400" cy="3931920"/>
+          </a:xfrm>
+          <a:prstGeom prst="rect">
+            <a:avLst/>
+          </a:prstGeom>
+        </p:spPr>
+      </p:pic>
+      <p:sp>
+        <p:nvSpPr>
+          <p:cNvPr id="6" name="TextBox 5"/>
+          <p:cNvSpPr txBox="1"/>
+          <p:nvPr/>
+        </p:nvSpPr>
+        <p:spPr>
+          <a:xfrm>
+            <a:off x="822960" y="5532120"/>
+            <a:ext cx="5486400" cy="548640"/>
+          </a:xfrm>
+          <a:prstGeom prst="rect">
+            <a:avLst/>
+          </a:prstGeom>
+          <a:noFill/>
+        </p:spPr>
+        <p:txBody>
+          <a:bodyPr wrap="none">
+            <a:spAutoFit/>
+          </a:bodyPr>
+          <a:lstStyle/>
+          <a:p>
+            <a:r>
+              <a:rPr sz="950" b="1">
+                <a:solidFill>
+                  <a:srgbClr val="64748B"/>
+                </a:solidFill>
+              </a:rPr>
+              <a:t>VeriSight Unified Git Diff Patch with Automated Sandbox Verification</a:t>
+            </a:r>
+          </a:p>
+        </p:txBody>
+      </p:sp>
+      <p:sp>
+        <p:nvSpPr>
+          <p:cNvPr id="7" name="Rounded Rectangle 6"/>
+          <p:cNvSpPr/>
+          <p:nvPr/>
+        </p:nvSpPr>
+        <p:spPr>
+          <a:xfrm>
+            <a:off x="6583680" y="1371600"/>
+            <a:ext cx="4846320" cy="4846320"/>
           </a:xfrm>
           <a:prstGeom prst="roundRect">
             <a:avLst/>
@@ -8951,14 +9035,14 @@
       </p:sp>
       <p:sp>
         <p:nvSpPr>
-          <p:cNvPr id="5" name="TextBox 4"/>
+          <p:cNvPr id="8" name="TextBox 7"/>
           <p:cNvSpPr txBox="1"/>
           <p:nvPr/>
         </p:nvSpPr>
         <p:spPr>
           <a:xfrm>
-            <a:off x="914400" y="1645920"/>
-            <a:ext cx="3063240" cy="4297680"/>
+            <a:off x="6766560" y="1508760"/>
+            <a:ext cx="4480560" cy="4572000"/>
           </a:xfrm>
           <a:prstGeom prst="rect">
             <a:avLst/>
@@ -8972,240 +9056,93 @@
           <a:lstStyle/>
           <a:p>
             <a:r>
-              <a:rPr sz="1300" b="1">
+              <a:rPr sz="1400" b="1">
+                <a:solidFill>
+                  <a:srgbClr val="0B4D32"/>
+                </a:solidFill>
+              </a:rPr>
+              <a:t>The Zero-Touch Repair Loop
+</a:t>
+            </a:r>
+          </a:p>
+          <a:p>
+            <a:r>
+              <a:rPr b="1" sz="1050">
                 <a:solidFill>
                   <a:srgbClr val="0F172A"/>
                 </a:solidFill>
               </a:rPr>
-              <a:t>Cloud API Cost per Run
+              <a:t>1. Minimal Git Diff
 </a:t>
             </a:r>
-          </a:p>
-          <a:p>
-            <a:r>
-              <a:rPr sz="2100" b="1">
-                <a:solidFill>
-                  <a:srgbClr val="0B4D32"/>
-                </a:solidFill>
-              </a:rPr>
-              <a:t>$0.02 - $0.05
+            <a:r>
+              <a:rPr sz="950">
+                <a:solidFill>
+                  <a:srgbClr val="334155"/>
+                </a:solidFill>
+              </a:rPr>
+              <a:t>Synthesizes surgical diff altering only the root-cause bug line without unintended side effects.
 </a:t>
             </a:r>
           </a:p>
           <a:p>
             <a:r>
-              <a:rPr sz="1000">
+              <a:rPr b="1" sz="1050">
+                <a:solidFill>
+                  <a:srgbClr val="0F172A"/>
+                </a:solidFill>
+              </a:rPr>
+              <a:t>2. AST Syntax Pre-Check
+</a:t>
+            </a:r>
+            <a:r>
+              <a:rPr sz="950">
                 <a:solidFill>
                   <a:srgbClr val="334155"/>
                 </a:solidFill>
               </a:rPr>
-              <a:t>• Using Gemini 2.5 Flash or Claude 3.5 Sonnet: Average 12k tokens per complete debug run.
-• An entire 1,000-test regression costs under $35 total.
-• Over 99% cheaper than human engineer hourly rates ($75-$150/hr).</a:t>
-            </a:r>
-          </a:p>
-        </p:txBody>
-      </p:sp>
-      <p:sp>
-        <p:nvSpPr>
-          <p:cNvPr id="6" name="Rounded Rectangle 5"/>
-          <p:cNvSpPr/>
-          <p:nvPr/>
-        </p:nvSpPr>
-        <p:spPr>
-          <a:xfrm>
-            <a:off x="4343400" y="1371600"/>
-            <a:ext cx="3429000" cy="4846320"/>
-          </a:xfrm>
-          <a:prstGeom prst="roundRect">
-            <a:avLst/>
-          </a:prstGeom>
-          <a:solidFill>
-            <a:srgbClr val="FFFFFF"/>
-          </a:solidFill>
-          <a:ln w="12700">
-            <a:solidFill>
-              <a:srgbClr val="0284C7"/>
-            </a:solidFill>
-          </a:ln>
-        </p:spPr>
-        <p:style>
-          <a:lnRef idx="1">
-            <a:schemeClr val="accent1"/>
-          </a:lnRef>
-          <a:fillRef idx="3">
-            <a:schemeClr val="accent1"/>
-          </a:fillRef>
-          <a:effectRef idx="2">
-            <a:schemeClr val="accent1"/>
-          </a:effectRef>
-          <a:fontRef idx="minor">
-            <a:schemeClr val="lt1"/>
-          </a:fontRef>
-        </p:style>
-        <p:txBody>
-          <a:bodyPr rtlCol="0" anchor="ctr"/>
-          <a:lstStyle/>
-          <a:p>
-            <a:pPr algn="ctr"/>
-          </a:p>
-        </p:txBody>
-      </p:sp>
-      <p:sp>
-        <p:nvSpPr>
-          <p:cNvPr id="7" name="TextBox 6"/>
-          <p:cNvSpPr txBox="1"/>
-          <p:nvPr/>
-        </p:nvSpPr>
-        <p:spPr>
-          <a:xfrm>
-            <a:off x="4526280" y="1645920"/>
-            <a:ext cx="3063240" cy="4297680"/>
-          </a:xfrm>
-          <a:prstGeom prst="rect">
-            <a:avLst/>
-          </a:prstGeom>
-          <a:noFill/>
-        </p:spPr>
-        <p:txBody>
-          <a:bodyPr wrap="square">
-            <a:spAutoFit/>
-          </a:bodyPr>
-          <a:lstStyle/>
-          <a:p>
-            <a:r>
-              <a:rPr sz="1300" b="1">
+              <a:t>Parses modified HDL with pyslang (Slang frontend) to catch genuine syntax errors before saving — distinguishing syntax errors from missing macros.
+</a:t>
+            </a:r>
+          </a:p>
+          <a:p>
+            <a:r>
+              <a:rPr b="1" sz="1050">
                 <a:solidFill>
                   <a:srgbClr val="0F172A"/>
                 </a:solidFill>
               </a:rPr>
-              <a:t>Sovereign Offline Cost
+              <a:t>3. Isolated Sandbox Simulation
 </a:t>
             </a:r>
-          </a:p>
-          <a:p>
-            <a:r>
-              <a:rPr sz="2100" b="1">
-                <a:solidFill>
-                  <a:srgbClr val="0284C7"/>
-                </a:solidFill>
-              </a:rPr>
-              <a:t>$0.00 Marginal Cost
+            <a:r>
+              <a:rPr sz="950">
+                <a:solidFill>
+                  <a:srgbClr val="334155"/>
+                </a:solidFill>
+              </a:rPr>
+              <a:t>Copies patched design into /tmp sandbox and re-executes original simulation using the active EDA tool.
 </a:t>
             </a:r>
           </a:p>
           <a:p>
             <a:r>
-              <a:rPr sz="1000">
+              <a:rPr b="1" sz="1050">
+                <a:solidFill>
+                  <a:srgbClr val="0F172A"/>
+                </a:solidFill>
+              </a:rPr>
+              <a:t>4. Regression Clean Sign-Off
+</a:t>
+            </a:r>
+            <a:r>
+              <a:rPr sz="950">
                 <a:solidFill>
                   <a:srgbClr val="334155"/>
                 </a:solidFill>
               </a:rPr>
-              <a:t>• Deployable on on-premise GPU servers using local Ollama or vLLM.
-• Runs DeepSeek-Coder-V2 or Llama-3-70B with air-gapped zero external data transfer.
-• Guarantees 100% silicon IP confidentiality and IT security compliance.</a:t>
-            </a:r>
-          </a:p>
-        </p:txBody>
-      </p:sp>
-      <p:sp>
-        <p:nvSpPr>
-          <p:cNvPr id="8" name="Rounded Rectangle 7"/>
-          <p:cNvSpPr/>
-          <p:nvPr/>
-        </p:nvSpPr>
-        <p:spPr>
-          <a:xfrm>
-            <a:off x="7955280" y="1371600"/>
-            <a:ext cx="3429000" cy="4846320"/>
-          </a:xfrm>
-          <a:prstGeom prst="roundRect">
-            <a:avLst/>
-          </a:prstGeom>
-          <a:solidFill>
-            <a:srgbClr val="FFFFFF"/>
-          </a:solidFill>
-          <a:ln w="12700">
-            <a:solidFill>
-              <a:srgbClr val="D97706"/>
-            </a:solidFill>
-          </a:ln>
-        </p:spPr>
-        <p:style>
-          <a:lnRef idx="1">
-            <a:schemeClr val="accent1"/>
-          </a:lnRef>
-          <a:fillRef idx="3">
-            <a:schemeClr val="accent1"/>
-          </a:fillRef>
-          <a:effectRef idx="2">
-            <a:schemeClr val="accent1"/>
-          </a:effectRef>
-          <a:fontRef idx="minor">
-            <a:schemeClr val="lt1"/>
-          </a:fontRef>
-        </p:style>
-        <p:txBody>
-          <a:bodyPr rtlCol="0" anchor="ctr"/>
-          <a:lstStyle/>
-          <a:p>
-            <a:pPr algn="ctr"/>
-          </a:p>
-        </p:txBody>
-      </p:sp>
-      <p:sp>
-        <p:nvSpPr>
-          <p:cNvPr id="9" name="TextBox 8"/>
-          <p:cNvSpPr txBox="1"/>
-          <p:nvPr/>
-        </p:nvSpPr>
-        <p:spPr>
-          <a:xfrm>
-            <a:off x="8138160" y="1645920"/>
-            <a:ext cx="3063240" cy="4297680"/>
-          </a:xfrm>
-          <a:prstGeom prst="rect">
-            <a:avLst/>
-          </a:prstGeom>
-          <a:noFill/>
-        </p:spPr>
-        <p:txBody>
-          <a:bodyPr wrap="square">
-            <a:spAutoFit/>
-          </a:bodyPr>
-          <a:lstStyle/>
-          <a:p>
-            <a:r>
-              <a:rPr sz="1300" b="1">
-                <a:solidFill>
-                  <a:srgbClr val="0F172A"/>
-                </a:solidFill>
-              </a:rPr>
-              <a:t>AST Token Optimization
+              <a:t>Confirms failing assertion is eliminated and all existing regression tests continue to pass.
 </a:t>
-            </a:r>
-          </a:p>
-          <a:p>
-            <a:r>
-              <a:rPr sz="2100" b="1">
-                <a:solidFill>
-                  <a:srgbClr val="D97706"/>
-                </a:solidFill>
-              </a:rPr>
-              <a:t>84% Token Reduction
-</a:t>
-            </a:r>
-          </a:p>
-          <a:p>
-            <a:r>
-              <a:rPr sz="1000">
-                <a:solidFill>
-                  <a:srgbClr val="334155"/>
-                </a:solidFill>
-              </a:rPr>
-              <a:t>• pyslang AST pruning and targeted log slicing strip out 84% of irrelevant tokens before reaching LLM context.
-• Feeds strictly relevant logic cone to context.
-• Prevents prompt bloat and achieves sub-15s response latency.</a:t>
             </a:r>
           </a:p>
         </p:txBody>
@@ -9227,13 +9164,13 @@
               <p:cTn id="2" dur="indefinite" nodeType="mainSeq">
                 <p:childTnLst>
                   <p:par>
-                    <p:cTn id="9" fill="hold">
+                    <p:cTn id="12" fill="hold">
                       <p:stCondLst>
                         <p:cond delay="indefinite"/>
                       </p:stCondLst>
                       <p:childTnLst>
                         <p:par>
-                          <p:cTn id="10" fill="hold">
+                          <p:cTn id="13" fill="hold">
                             <p:stCondLst>
                               <p:cond delay="0"/>
                             </p:stCondLst>
@@ -9310,33 +9247,15 @@
                                   </p:childTnLst>
                                 </p:cTn>
                               </p:par>
-                            </p:childTnLst>
-                          </p:cTn>
-                        </p:par>
-                      </p:childTnLst>
-                    </p:cTn>
-                  </p:par>
-                  <p:par>
-                    <p:cTn id="17" fill="hold">
-                      <p:stCondLst>
-                        <p:cond delay="indefinite"/>
-                      </p:stCondLst>
-                      <p:childTnLst>
-                        <p:par>
-                          <p:cTn id="18" fill="hold">
-                            <p:stCondLst>
-                              <p:cond delay="0"/>
-                            </p:stCondLst>
-                            <p:childTnLst>
                               <p:par>
-                                <p:cTn id="11" presetID="10" presetClass="entr" presetSubtype="0" fill="hold" grpId="0" nodeType="clickEffect">
+                                <p:cTn id="9" presetID="10" presetClass="entr" presetSubtype="0" fill="hold" grpId="0" nodeType="withEffect">
                                   <p:stCondLst>
                                     <p:cond delay="0"/>
                                   </p:stCondLst>
                                   <p:childTnLst>
                                     <p:set>
                                       <p:cBhvr>
-                                        <p:cTn id="12" dur="1" fill="hold">
+                                        <p:cTn id="10" dur="1" fill="hold">
                                           <p:stCondLst>
                                             <p:cond delay="0"/>
                                           </p:stCondLst>
@@ -9354,45 +9273,9 @@
                                     </p:set>
                                     <p:animEffect transition="in" filter="fade">
                                       <p:cBhvr>
-                                        <p:cTn id="13" dur="500">
+                                        <p:cTn id="11" dur="500">
                                           <p:tgtEl>
                                             <p:spTgt spid="6"/>
-                                          </p:tgtEl>
-                                        </p:cTn>
-                                      </p:cBhvr>
-                                    </p:animEffect>
-                                  </p:childTnLst>
-                                </p:cTn>
-                              </p:par>
-                              <p:par>
-                                <p:cTn id="14" presetID="10" presetClass="entr" presetSubtype="0" fill="hold" grpId="0" nodeType="withEffect">
-                                  <p:stCondLst>
-                                    <p:cond delay="0"/>
-                                  </p:stCondLst>
-                                  <p:childTnLst>
-                                    <p:set>
-                                      <p:cBhvr>
-                                        <p:cTn id="15" dur="1" fill="hold">
-                                          <p:stCondLst>
-                                            <p:cond delay="0"/>
-                                          </p:stCondLst>
-                                        </p:cTn>
-                                        <p:tgtEl>
-                                          <p:spTgt spid="7"/>
-                                        </p:tgtEl>
-                                        <p:attrNameLst>
-                                          <p:attrName>style.visibility</p:attrName>
-                                        </p:attrNameLst>
-                                      </p:cBhvr>
-                                      <p:to>
-                                        <p:strVal val="visible"/>
-                                      </p:to>
-                                    </p:set>
-                                    <p:animEffect transition="in" filter="fade">
-                                      <p:cBhvr>
-                                        <p:cTn id="16" dur="500">
-                                          <p:tgtEl>
-                                            <p:spTgt spid="7"/>
                                           </p:tgtEl>
                                         </p:cTn>
                                       </p:cBhvr>
@@ -9407,26 +9290,62 @@
                     </p:cTn>
                   </p:par>
                   <p:par>
-                    <p:cTn id="25" fill="hold">
+                    <p:cTn id="20" fill="hold">
                       <p:stCondLst>
                         <p:cond delay="indefinite"/>
                       </p:stCondLst>
                       <p:childTnLst>
                         <p:par>
-                          <p:cTn id="26" fill="hold">
+                          <p:cTn id="21" fill="hold">
                             <p:stCondLst>
                               <p:cond delay="0"/>
                             </p:stCondLst>
                             <p:childTnLst>
                               <p:par>
-                                <p:cTn id="19" presetID="10" presetClass="entr" presetSubtype="0" fill="hold" grpId="0" nodeType="clickEffect">
+                                <p:cTn id="14" presetID="10" presetClass="entr" presetSubtype="0" fill="hold" grpId="0" nodeType="clickEffect">
                                   <p:stCondLst>
                                     <p:cond delay="0"/>
                                   </p:stCondLst>
                                   <p:childTnLst>
                                     <p:set>
                                       <p:cBhvr>
-                                        <p:cTn id="20" dur="1" fill="hold">
+                                        <p:cTn id="15" dur="1" fill="hold">
+                                          <p:stCondLst>
+                                            <p:cond delay="0"/>
+                                          </p:stCondLst>
+                                        </p:cTn>
+                                        <p:tgtEl>
+                                          <p:spTgt spid="7"/>
+                                        </p:tgtEl>
+                                        <p:attrNameLst>
+                                          <p:attrName>style.visibility</p:attrName>
+                                        </p:attrNameLst>
+                                      </p:cBhvr>
+                                      <p:to>
+                                        <p:strVal val="visible"/>
+                                      </p:to>
+                                    </p:set>
+                                    <p:animEffect transition="in" filter="fade">
+                                      <p:cBhvr>
+                                        <p:cTn id="16" dur="500">
+                                          <p:tgtEl>
+                                            <p:spTgt spid="7"/>
+                                          </p:tgtEl>
+                                        </p:cTn>
+                                      </p:cBhvr>
+                                    </p:animEffect>
+                                  </p:childTnLst>
+                                </p:cTn>
+                              </p:par>
+                              <p:par>
+                                <p:cTn id="17" presetID="10" presetClass="entr" presetSubtype="0" fill="hold" grpId="0" nodeType="withEffect">
+                                  <p:stCondLst>
+                                    <p:cond delay="0"/>
+                                  </p:stCondLst>
+                                  <p:childTnLst>
+                                    <p:set>
+                                      <p:cBhvr>
+                                        <p:cTn id="18" dur="1" fill="hold">
                                           <p:stCondLst>
                                             <p:cond delay="0"/>
                                           </p:stCondLst>
@@ -9444,45 +9363,9 @@
                                     </p:set>
                                     <p:animEffect transition="in" filter="fade">
                                       <p:cBhvr>
-                                        <p:cTn id="21" dur="500">
+                                        <p:cTn id="19" dur="500">
                                           <p:tgtEl>
                                             <p:spTgt spid="8"/>
-                                          </p:tgtEl>
-                                        </p:cTn>
-                                      </p:cBhvr>
-                                    </p:animEffect>
-                                  </p:childTnLst>
-                                </p:cTn>
-                              </p:par>
-                              <p:par>
-                                <p:cTn id="22" presetID="10" presetClass="entr" presetSubtype="0" fill="hold" grpId="0" nodeType="withEffect">
-                                  <p:stCondLst>
-                                    <p:cond delay="0"/>
-                                  </p:stCondLst>
-                                  <p:childTnLst>
-                                    <p:set>
-                                      <p:cBhvr>
-                                        <p:cTn id="23" dur="1" fill="hold">
-                                          <p:stCondLst>
-                                            <p:cond delay="0"/>
-                                          </p:stCondLst>
-                                        </p:cTn>
-                                        <p:tgtEl>
-                                          <p:spTgt spid="9"/>
-                                        </p:tgtEl>
-                                        <p:attrNameLst>
-                                          <p:attrName>style.visibility</p:attrName>
-                                        </p:attrNameLst>
-                                      </p:cBhvr>
-                                      <p:to>
-                                        <p:strVal val="visible"/>
-                                      </p:to>
-                                    </p:set>
-                                    <p:animEffect transition="in" filter="fade">
-                                      <p:cBhvr>
-                                        <p:cTn id="24" dur="500">
-                                          <p:tgtEl>
-                                            <p:spTgt spid="9"/>
                                           </p:tgtEl>
                                         </p:cTn>
                                       </p:cBhvr>
@@ -9523,7 +9406,6 @@
       <p:bldP spid="6" grpId="0" bldLvl="0" animBg="1"/>
       <p:bldP spid="7" grpId="0" bldLvl="0" animBg="1"/>
       <p:bldP spid="8" grpId="0" bldLvl="0" animBg="1"/>
-      <p:bldP spid="9" grpId="0" bldLvl="0" animBg="1"/>
     </p:bldLst>
   </p:timing>
 </p:sld>
@@ -9592,7 +9474,7 @@
                 </a:solidFill>
                 <a:latin typeface="Arial"/>
               </a:rPr>
-              <a:t>STRATEGIC ADVANTAGE  •  </a:t>
+              <a:t>COST EFFICIENCY  •  </a:t>
             </a:r>
             <a:r>
               <a:rPr sz="2100" b="1">
@@ -9601,7 +9483,7 @@
                 </a:solidFill>
                 <a:latin typeface="Arial"/>
               </a:rPr>
-              <a:t>Topic 11: Summary — The VeriSight Defensible Moat</a:t>
+              <a:t>Topic 10: Token Utilization Over Cost — Sovereign Economics</a:t>
             </a:r>
           </a:p>
         </p:txBody>
@@ -9615,7 +9497,7 @@
         <p:spPr>
           <a:xfrm>
             <a:off x="731520" y="1371600"/>
-            <a:ext cx="5212080" cy="2286000"/>
+            <a:ext cx="3429000" cy="4846320"/>
           </a:xfrm>
           <a:prstGeom prst="roundRect">
             <a:avLst/>
@@ -9659,8 +9541,8 @@
         </p:nvSpPr>
         <p:spPr>
           <a:xfrm>
-            <a:off x="960120" y="1554480"/>
-            <a:ext cx="4754880" cy="1920240"/>
+            <a:off x="914400" y="1645920"/>
+            <a:ext cx="3063240" cy="4297680"/>
           </a:xfrm>
           <a:prstGeom prst="rect">
             <a:avLst/>
@@ -9674,12 +9556,23 @@
           <a:lstStyle/>
           <a:p>
             <a:r>
-              <a:rPr sz="1350" b="1">
+              <a:rPr sz="1300" b="1">
+                <a:solidFill>
+                  <a:srgbClr val="0F172A"/>
+                </a:solidFill>
+              </a:rPr>
+              <a:t>Cloud API Cost per Run
+</a:t>
+            </a:r>
+          </a:p>
+          <a:p>
+            <a:r>
+              <a:rPr sz="2100" b="1">
                 <a:solidFill>
                   <a:srgbClr val="0B4D32"/>
                 </a:solidFill>
               </a:rPr>
-              <a:t>Deep Domain Grounding
+              <a:t>$0.02 - $0.05
 </a:t>
             </a:r>
           </a:p>
@@ -9690,8 +9583,9 @@
                   <a:srgbClr val="334155"/>
                 </a:solidFill>
               </a:rPr>
-              <a:t>• Not a generic LLM wrapper: Built on 9 formal decision rules, pyslang elaborated AST, and temporal waveform slicing.
-• Truly understands 4-state simulation (X/Z), CDC synchronizers, and UVM TLM transactions.</a:t>
+              <a:t>• Using Gemini 2.5 Flash or Claude 3.5 Sonnet: Average 12k tokens per complete debug run.
+• An entire 1,000-test regression costs under $35 total.
+• Over 99% cheaper than human engineer hourly rates ($75-$150/hr).</a:t>
             </a:r>
           </a:p>
         </p:txBody>
@@ -9704,8 +9598,8 @@
         </p:nvSpPr>
         <p:spPr>
           <a:xfrm>
-            <a:off x="6126480" y="1371600"/>
-            <a:ext cx="5212080" cy="2286000"/>
+            <a:off x="4343400" y="1371600"/>
+            <a:ext cx="3429000" cy="4846320"/>
           </a:xfrm>
           <a:prstGeom prst="roundRect">
             <a:avLst/>
@@ -9749,8 +9643,8 @@
         </p:nvSpPr>
         <p:spPr>
           <a:xfrm>
-            <a:off x="6355080" y="1554480"/>
-            <a:ext cx="4754880" cy="1920240"/>
+            <a:off x="4526280" y="1645920"/>
+            <a:ext cx="3063240" cy="4297680"/>
           </a:xfrm>
           <a:prstGeom prst="rect">
             <a:avLst/>
@@ -9764,12 +9658,23 @@
           <a:lstStyle/>
           <a:p>
             <a:r>
-              <a:rPr sz="1350" b="1">
+              <a:rPr sz="1300" b="1">
+                <a:solidFill>
+                  <a:srgbClr val="0F172A"/>
+                </a:solidFill>
+              </a:rPr>
+              <a:t>Sovereign Offline Cost
+</a:t>
+            </a:r>
+          </a:p>
+          <a:p>
+            <a:r>
+              <a:rPr sz="2100" b="1">
                 <a:solidFill>
                   <a:srgbClr val="0284C7"/>
                 </a:solidFill>
               </a:rPr>
-              <a:t>Air-Gapped Sovereign Security
+              <a:t>$0.00 Marginal Cost
 </a:t>
             </a:r>
           </a:p>
@@ -9780,8 +9685,9 @@
                   <a:srgbClr val="334155"/>
                 </a:solidFill>
               </a:rPr>
-              <a:t>• Semiconductor IP never leaves customer premises when running sovereign local mode.
-• Compatible with defense, aerospace, and high-security fabless semiconductor security policies.</a:t>
+              <a:t>• Deployable on on-premise GPU servers using local Ollama or vLLM.
+• Runs DeepSeek-Coder-V2 or Llama-3-70B with air-gapped zero external data transfer.
+• Guarantees 100% silicon IP confidentiality and IT security compliance.</a:t>
             </a:r>
           </a:p>
         </p:txBody>
@@ -9794,8 +9700,8 @@
         </p:nvSpPr>
         <p:spPr>
           <a:xfrm>
-            <a:off x="731520" y="3840480"/>
-            <a:ext cx="5212080" cy="2286000"/>
+            <a:off x="7955280" y="1371600"/>
+            <a:ext cx="3429000" cy="4846320"/>
           </a:xfrm>
           <a:prstGeom prst="roundRect">
             <a:avLst/>
@@ -9839,8 +9745,8 @@
         </p:nvSpPr>
         <p:spPr>
           <a:xfrm>
-            <a:off x="960120" y="4023360"/>
-            <a:ext cx="4754880" cy="1920240"/>
+            <a:off x="8138160" y="1645920"/>
+            <a:ext cx="3063240" cy="4297680"/>
           </a:xfrm>
           <a:prstGeom prst="rect">
             <a:avLst/>
@@ -9854,12 +9760,23 @@
           <a:lstStyle/>
           <a:p>
             <a:r>
-              <a:rPr sz="1350" b="1">
+              <a:rPr sz="1300" b="1">
+                <a:solidFill>
+                  <a:srgbClr val="0F172A"/>
+                </a:solidFill>
+              </a:rPr>
+              <a:t>AST Token Optimization
+</a:t>
+            </a:r>
+          </a:p>
+          <a:p>
+            <a:r>
+              <a:rPr sz="2100" b="1">
                 <a:solidFill>
                   <a:srgbClr val="D97706"/>
                 </a:solidFill>
               </a:rPr>
-              <a:t>Zero Vendor Lock-In
+              <a:t>84% Token Reduction
 </a:t>
             </a:r>
           </a:p>
@@ -9870,98 +9787,9 @@
                   <a:srgbClr val="334155"/>
                 </a:solidFill>
               </a:rPr>
-              <a:t>• Seamless Day-1 abstraction layer sitting above Synopsys VCS, Siemens Questa, Cadence Xcelium, and Verilator.
-• Drop-in integration into existing Makefiles, run scripts, and regression managers.</a:t>
-            </a:r>
-          </a:p>
-        </p:txBody>
-      </p:sp>
-      <p:sp>
-        <p:nvSpPr>
-          <p:cNvPr id="10" name="Rounded Rectangle 9"/>
-          <p:cNvSpPr/>
-          <p:nvPr/>
-        </p:nvSpPr>
-        <p:spPr>
-          <a:xfrm>
-            <a:off x="6126480" y="3840480"/>
-            <a:ext cx="5212080" cy="2286000"/>
-          </a:xfrm>
-          <a:prstGeom prst="roundRect">
-            <a:avLst/>
-          </a:prstGeom>
-          <a:solidFill>
-            <a:srgbClr val="FFFFFF"/>
-          </a:solidFill>
-          <a:ln w="12700">
-            <a:solidFill>
-              <a:srgbClr val="0B4D32"/>
-            </a:solidFill>
-          </a:ln>
-        </p:spPr>
-        <p:style>
-          <a:lnRef idx="1">
-            <a:schemeClr val="accent1"/>
-          </a:lnRef>
-          <a:fillRef idx="3">
-            <a:schemeClr val="accent1"/>
-          </a:fillRef>
-          <a:effectRef idx="2">
-            <a:schemeClr val="accent1"/>
-          </a:effectRef>
-          <a:fontRef idx="minor">
-            <a:schemeClr val="lt1"/>
-          </a:fontRef>
-        </p:style>
-        <p:txBody>
-          <a:bodyPr rtlCol="0" anchor="ctr"/>
-          <a:lstStyle/>
-          <a:p>
-            <a:pPr algn="ctr"/>
-          </a:p>
-        </p:txBody>
-      </p:sp>
-      <p:sp>
-        <p:nvSpPr>
-          <p:cNvPr id="11" name="TextBox 10"/>
-          <p:cNvSpPr txBox="1"/>
-          <p:nvPr/>
-        </p:nvSpPr>
-        <p:spPr>
-          <a:xfrm>
-            <a:off x="6355080" y="4023360"/>
-            <a:ext cx="4754880" cy="1920240"/>
-          </a:xfrm>
-          <a:prstGeom prst="rect">
-            <a:avLst/>
-          </a:prstGeom>
-          <a:noFill/>
-        </p:spPr>
-        <p:txBody>
-          <a:bodyPr wrap="square">
-            <a:spAutoFit/>
-          </a:bodyPr>
-          <a:lstStyle/>
-          <a:p>
-            <a:r>
-              <a:rPr sz="1350" b="1">
-                <a:solidFill>
-                  <a:srgbClr val="0B4D32"/>
-                </a:solidFill>
-              </a:rPr>
-              <a:t>Massive Enterprise ROI
-</a:t>
-            </a:r>
-          </a:p>
-          <a:p>
-            <a:r>
-              <a:rPr sz="1000">
-                <a:solidFill>
-                  <a:srgbClr val="334155"/>
-                </a:solidFill>
-              </a:rPr>
-              <a:t>• Reduces triage turnaround time from 4-6 hours to &lt;15 seconds (99.3% acceleration).
-• Eliminates multi-million dollar physical mask re-spins and accelerates time-to-market by 6-10 weeks.</a:t>
+              <a:t>• pyslang AST pruning and targeted log slicing strip out 84% of irrelevant tokens before reaching LLM context.
+• Feeds strictly relevant logic cone to context.
+• Prevents prompt bloat and achieves sub-15s response latency.</a:t>
             </a:r>
           </a:p>
         </p:txBody>
@@ -10239,96 +10067,6 @@
                                         <p:cTn id="24" dur="500">
                                           <p:tgtEl>
                                             <p:spTgt spid="9"/>
-                                          </p:tgtEl>
-                                        </p:cTn>
-                                      </p:cBhvr>
-                                    </p:animEffect>
-                                  </p:childTnLst>
-                                </p:cTn>
-                              </p:par>
-                            </p:childTnLst>
-                          </p:cTn>
-                        </p:par>
-                      </p:childTnLst>
-                    </p:cTn>
-                  </p:par>
-                  <p:par>
-                    <p:cTn id="33" fill="hold">
-                      <p:stCondLst>
-                        <p:cond delay="indefinite"/>
-                      </p:stCondLst>
-                      <p:childTnLst>
-                        <p:par>
-                          <p:cTn id="34" fill="hold">
-                            <p:stCondLst>
-                              <p:cond delay="0"/>
-                            </p:stCondLst>
-                            <p:childTnLst>
-                              <p:par>
-                                <p:cTn id="27" presetID="10" presetClass="entr" presetSubtype="0" fill="hold" grpId="0" nodeType="clickEffect">
-                                  <p:stCondLst>
-                                    <p:cond delay="0"/>
-                                  </p:stCondLst>
-                                  <p:childTnLst>
-                                    <p:set>
-                                      <p:cBhvr>
-                                        <p:cTn id="28" dur="1" fill="hold">
-                                          <p:stCondLst>
-                                            <p:cond delay="0"/>
-                                          </p:stCondLst>
-                                        </p:cTn>
-                                        <p:tgtEl>
-                                          <p:spTgt spid="10"/>
-                                        </p:tgtEl>
-                                        <p:attrNameLst>
-                                          <p:attrName>style.visibility</p:attrName>
-                                        </p:attrNameLst>
-                                      </p:cBhvr>
-                                      <p:to>
-                                        <p:strVal val="visible"/>
-                                      </p:to>
-                                    </p:set>
-                                    <p:animEffect transition="in" filter="fade">
-                                      <p:cBhvr>
-                                        <p:cTn id="29" dur="500">
-                                          <p:tgtEl>
-                                            <p:spTgt spid="10"/>
-                                          </p:tgtEl>
-                                        </p:cTn>
-                                      </p:cBhvr>
-                                    </p:animEffect>
-                                  </p:childTnLst>
-                                </p:cTn>
-                              </p:par>
-                              <p:par>
-                                <p:cTn id="30" presetID="10" presetClass="entr" presetSubtype="0" fill="hold" grpId="0" nodeType="withEffect">
-                                  <p:stCondLst>
-                                    <p:cond delay="0"/>
-                                  </p:stCondLst>
-                                  <p:childTnLst>
-                                    <p:set>
-                                      <p:cBhvr>
-                                        <p:cTn id="31" dur="1" fill="hold">
-                                          <p:stCondLst>
-                                            <p:cond delay="0"/>
-                                          </p:stCondLst>
-                                        </p:cTn>
-                                        <p:tgtEl>
-                                          <p:spTgt spid="11"/>
-                                        </p:tgtEl>
-                                        <p:attrNameLst>
-                                          <p:attrName>style.visibility</p:attrName>
-                                        </p:attrNameLst>
-                                      </p:cBhvr>
-                                      <p:to>
-                                        <p:strVal val="visible"/>
-                                      </p:to>
-                                    </p:set>
-                                    <p:animEffect transition="in" filter="fade">
-                                      <p:cBhvr>
-                                        <p:cTn id="32" dur="500">
-                                          <p:tgtEl>
-                                            <p:spTgt spid="11"/>
                                           </p:tgtEl>
                                         </p:cTn>
                                       </p:cBhvr>
@@ -10370,8 +10108,6 @@
       <p:bldP spid="7" grpId="0" bldLvl="0" animBg="1"/>
       <p:bldP spid="8" grpId="0" bldLvl="0" animBg="1"/>
       <p:bldP spid="9" grpId="0" bldLvl="0" animBg="1"/>
-      <p:bldP spid="10" grpId="0" bldLvl="0" animBg="1"/>
-      <p:bldP spid="11" grpId="0" bldLvl="0" animBg="1"/>
     </p:bldLst>
   </p:timing>
 </p:sld>
@@ -10440,7 +10176,7 @@
                 </a:solidFill>
                 <a:latin typeface="Arial"/>
               </a:rPr>
-              <a:t>PRODUCT ROADMAP  •  </a:t>
+              <a:t>STRATEGIC ADVANTAGE  •  </a:t>
             </a:r>
             <a:r>
               <a:rPr sz="2100" b="1">
@@ -10449,7 +10185,7 @@
                 </a:solidFill>
                 <a:latin typeface="Arial"/>
               </a:rPr>
-              <a:t>Topic 12: Future Scope — The Autonomous Silicon Roadmap</a:t>
+              <a:t>Topic 11: Summary — The VeriSight Defensible Moat</a:t>
             </a:r>
           </a:p>
         </p:txBody>
@@ -10463,7 +10199,7 @@
         <p:spPr>
           <a:xfrm>
             <a:off x="731520" y="1371600"/>
-            <a:ext cx="3429000" cy="4846320"/>
+            <a:ext cx="5212080" cy="2286000"/>
           </a:xfrm>
           <a:prstGeom prst="roundRect">
             <a:avLst/>
@@ -10507,8 +10243,8 @@
         </p:nvSpPr>
         <p:spPr>
           <a:xfrm>
-            <a:off x="914400" y="1554480"/>
-            <a:ext cx="3063240" cy="4480560"/>
+            <a:off x="960120" y="1554480"/>
+            <a:ext cx="4754880" cy="1920240"/>
           </a:xfrm>
           <a:prstGeom prst="rect">
             <a:avLst/>
@@ -10522,39 +10258,24 @@
           <a:lstStyle/>
           <a:p>
             <a:r>
-              <a:rPr sz="1300" b="1">
+              <a:rPr sz="1350" b="1">
                 <a:solidFill>
                   <a:srgbClr val="0B4D32"/>
                 </a:solidFill>
               </a:rPr>
-              <a:t>Phase 1: Present (v2.4)
+              <a:t>Deep Domain Grounding
 </a:t>
             </a:r>
           </a:p>
           <a:p>
             <a:r>
-              <a:rPr sz="1100" b="1">
-                <a:solidFill>
-                  <a:srgbClr val="0F172A"/>
-                </a:solidFill>
-              </a:rPr>
-              <a:t>Production Multi-Agent Triage
-</a:t>
-            </a:r>
-          </a:p>
-          <a:p>
-            <a:r>
-              <a:rPr sz="950">
+              <a:rPr sz="1000">
                 <a:solidFill>
                   <a:srgbClr val="334155"/>
                 </a:solidFill>
               </a:rPr>
-              <a:t>• 6 Guided Autonomous Workflows
-• 9 Formal RCA Decision Rules
-• pyslang IEEE-1800 AST X-Tracer
-• Live Coverage Cockpit &amp; Waveform Studio
-• Zero-Touch Sandbox Auto-Patching
-• FastAPI Asynchronous Web Studio</a:t>
+              <a:t>• Not a generic LLM wrapper: Built on 9 formal decision rules, pyslang elaborated AST, and temporal waveform slicing.
+• Truly understands 4-state simulation (X/Z), CDC synchronizers, and UVM TLM transactions.</a:t>
             </a:r>
           </a:p>
         </p:txBody>
@@ -10567,8 +10288,8 @@
         </p:nvSpPr>
         <p:spPr>
           <a:xfrm>
-            <a:off x="4343400" y="1371600"/>
-            <a:ext cx="3429000" cy="4846320"/>
+            <a:off x="6126480" y="1371600"/>
+            <a:ext cx="5212080" cy="2286000"/>
           </a:xfrm>
           <a:prstGeom prst="roundRect">
             <a:avLst/>
@@ -10612,8 +10333,8 @@
         </p:nvSpPr>
         <p:spPr>
           <a:xfrm>
-            <a:off x="4526280" y="1554480"/>
-            <a:ext cx="3063240" cy="4480560"/>
+            <a:off x="6355080" y="1554480"/>
+            <a:ext cx="4754880" cy="1920240"/>
           </a:xfrm>
           <a:prstGeom prst="rect">
             <a:avLst/>
@@ -10627,38 +10348,24 @@
           <a:lstStyle/>
           <a:p>
             <a:r>
-              <a:rPr sz="1300" b="1">
+              <a:rPr sz="1350" b="1">
                 <a:solidFill>
                   <a:srgbClr val="0284C7"/>
                 </a:solidFill>
               </a:rPr>
-              <a:t>Phase 2: Q1-Q2 2027
+              <a:t>Air-Gapped Sovereign Security
 </a:t>
             </a:r>
           </a:p>
           <a:p>
             <a:r>
-              <a:rPr sz="1100" b="1">
-                <a:solidFill>
-                  <a:srgbClr val="0F172A"/>
-                </a:solidFill>
-              </a:rPr>
-              <a:t>Continuous Regression Intelligence
-</a:t>
-            </a:r>
-          </a:p>
-          <a:p>
-            <a:r>
-              <a:rPr sz="950">
+              <a:rPr sz="1000">
                 <a:solidFill>
                   <a:srgbClr val="334155"/>
                 </a:solidFill>
               </a:rPr>
-              <a:t>• Nightly farm log clustering &amp; anomaly grouping
-• Automated test deduplication
-• Bayesian stimulus tuning for coverage holes
-• Cross-project historical defect memory
-• Automated Git Pull Request review comments</a:t>
+              <a:t>• Semiconductor IP never leaves customer premises when running sovereign local mode.
+• Compatible with defense, aerospace, and high-security fabless semiconductor security policies.</a:t>
             </a:r>
           </a:p>
         </p:txBody>
@@ -10671,8 +10378,8 @@
         </p:nvSpPr>
         <p:spPr>
           <a:xfrm>
-            <a:off x="7955280" y="1371600"/>
-            <a:ext cx="3429000" cy="4846320"/>
+            <a:off x="731520" y="3840480"/>
+            <a:ext cx="5212080" cy="2286000"/>
           </a:xfrm>
           <a:prstGeom prst="roundRect">
             <a:avLst/>
@@ -10716,8 +10423,8 @@
         </p:nvSpPr>
         <p:spPr>
           <a:xfrm>
-            <a:off x="8138160" y="1554480"/>
-            <a:ext cx="3063240" cy="4480560"/>
+            <a:off x="960120" y="4023360"/>
+            <a:ext cx="4754880" cy="1920240"/>
           </a:xfrm>
           <a:prstGeom prst="rect">
             <a:avLst/>
@@ -10731,38 +10438,114 @@
           <a:lstStyle/>
           <a:p>
             <a:r>
-              <a:rPr sz="1300" b="1">
+              <a:rPr sz="1350" b="1">
                 <a:solidFill>
                   <a:srgbClr val="D97706"/>
                 </a:solidFill>
               </a:rPr>
-              <a:t>Phase 3: Q3-Q4 2027
+              <a:t>Zero Vendor Lock-In
 </a:t>
             </a:r>
           </a:p>
           <a:p>
             <a:r>
-              <a:rPr sz="1100" b="1">
-                <a:solidFill>
-                  <a:srgbClr val="0F172A"/>
-                </a:solidFill>
-              </a:rPr>
-              <a:t>Silicon-to-Software Autonomous Loop
+              <a:rPr sz="1000">
+                <a:solidFill>
+                  <a:srgbClr val="334155"/>
+                </a:solidFill>
+              </a:rPr>
+              <a:t>• Seamless Day-1 abstraction layer sitting above Synopsys VCS, Siemens Questa, Cadence Xcelium, and Verilator.
+• Drop-in integration into existing Makefiles, run scripts, and regression managers.</a:t>
+            </a:r>
+          </a:p>
+        </p:txBody>
+      </p:sp>
+      <p:sp>
+        <p:nvSpPr>
+          <p:cNvPr id="10" name="Rounded Rectangle 9"/>
+          <p:cNvSpPr/>
+          <p:nvPr/>
+        </p:nvSpPr>
+        <p:spPr>
+          <a:xfrm>
+            <a:off x="6126480" y="3840480"/>
+            <a:ext cx="5212080" cy="2286000"/>
+          </a:xfrm>
+          <a:prstGeom prst="roundRect">
+            <a:avLst/>
+          </a:prstGeom>
+          <a:solidFill>
+            <a:srgbClr val="FFFFFF"/>
+          </a:solidFill>
+          <a:ln w="12700">
+            <a:solidFill>
+              <a:srgbClr val="0B4D32"/>
+            </a:solidFill>
+          </a:ln>
+        </p:spPr>
+        <p:style>
+          <a:lnRef idx="1">
+            <a:schemeClr val="accent1"/>
+          </a:lnRef>
+          <a:fillRef idx="3">
+            <a:schemeClr val="accent1"/>
+          </a:fillRef>
+          <a:effectRef idx="2">
+            <a:schemeClr val="accent1"/>
+          </a:effectRef>
+          <a:fontRef idx="minor">
+            <a:schemeClr val="lt1"/>
+          </a:fontRef>
+        </p:style>
+        <p:txBody>
+          <a:bodyPr rtlCol="0" anchor="ctr"/>
+          <a:lstStyle/>
+          <a:p>
+            <a:pPr algn="ctr"/>
+          </a:p>
+        </p:txBody>
+      </p:sp>
+      <p:sp>
+        <p:nvSpPr>
+          <p:cNvPr id="11" name="TextBox 10"/>
+          <p:cNvSpPr txBox="1"/>
+          <p:nvPr/>
+        </p:nvSpPr>
+        <p:spPr>
+          <a:xfrm>
+            <a:off x="6355080" y="4023360"/>
+            <a:ext cx="4754880" cy="1920240"/>
+          </a:xfrm>
+          <a:prstGeom prst="rect">
+            <a:avLst/>
+          </a:prstGeom>
+          <a:noFill/>
+        </p:spPr>
+        <p:txBody>
+          <a:bodyPr wrap="square">
+            <a:spAutoFit/>
+          </a:bodyPr>
+          <a:lstStyle/>
+          <a:p>
+            <a:r>
+              <a:rPr sz="1350" b="1">
+                <a:solidFill>
+                  <a:srgbClr val="0B4D32"/>
+                </a:solidFill>
+              </a:rPr>
+              <a:t>Massive Enterprise ROI
 </a:t>
             </a:r>
           </a:p>
           <a:p>
             <a:r>
-              <a:rPr sz="950">
+              <a:rPr sz="1000">
                 <a:solidFill>
                   <a:srgbClr val="334155"/>
                 </a:solidFill>
               </a:rPr>
-              <a:t>• Post-silicon ATE automated tester link
-• Scan chain fault diagnosis &amp; silicon debug
-• Automated ATPG test vector synthesis
-• Formal mathematical theorem proving
-• ISO 26262 ASIL-D safety lifecycle sign-off</a:t>
+              <a:t>• Reduces triage turnaround time from 4-6 hours to &lt;15 seconds (99.3% acceleration).
+• Eliminates multi-million dollar physical mask re-spins and accelerates time-to-market by 6-10 weeks.</a:t>
             </a:r>
           </a:p>
         </p:txBody>
@@ -11040,6 +10823,96 @@
                                         <p:cTn id="24" dur="500">
                                           <p:tgtEl>
                                             <p:spTgt spid="9"/>
+                                          </p:tgtEl>
+                                        </p:cTn>
+                                      </p:cBhvr>
+                                    </p:animEffect>
+                                  </p:childTnLst>
+                                </p:cTn>
+                              </p:par>
+                            </p:childTnLst>
+                          </p:cTn>
+                        </p:par>
+                      </p:childTnLst>
+                    </p:cTn>
+                  </p:par>
+                  <p:par>
+                    <p:cTn id="33" fill="hold">
+                      <p:stCondLst>
+                        <p:cond delay="indefinite"/>
+                      </p:stCondLst>
+                      <p:childTnLst>
+                        <p:par>
+                          <p:cTn id="34" fill="hold">
+                            <p:stCondLst>
+                              <p:cond delay="0"/>
+                            </p:stCondLst>
+                            <p:childTnLst>
+                              <p:par>
+                                <p:cTn id="27" presetID="10" presetClass="entr" presetSubtype="0" fill="hold" grpId="0" nodeType="clickEffect">
+                                  <p:stCondLst>
+                                    <p:cond delay="0"/>
+                                  </p:stCondLst>
+                                  <p:childTnLst>
+                                    <p:set>
+                                      <p:cBhvr>
+                                        <p:cTn id="28" dur="1" fill="hold">
+                                          <p:stCondLst>
+                                            <p:cond delay="0"/>
+                                          </p:stCondLst>
+                                        </p:cTn>
+                                        <p:tgtEl>
+                                          <p:spTgt spid="10"/>
+                                        </p:tgtEl>
+                                        <p:attrNameLst>
+                                          <p:attrName>style.visibility</p:attrName>
+                                        </p:attrNameLst>
+                                      </p:cBhvr>
+                                      <p:to>
+                                        <p:strVal val="visible"/>
+                                      </p:to>
+                                    </p:set>
+                                    <p:animEffect transition="in" filter="fade">
+                                      <p:cBhvr>
+                                        <p:cTn id="29" dur="500">
+                                          <p:tgtEl>
+                                            <p:spTgt spid="10"/>
+                                          </p:tgtEl>
+                                        </p:cTn>
+                                      </p:cBhvr>
+                                    </p:animEffect>
+                                  </p:childTnLst>
+                                </p:cTn>
+                              </p:par>
+                              <p:par>
+                                <p:cTn id="30" presetID="10" presetClass="entr" presetSubtype="0" fill="hold" grpId="0" nodeType="withEffect">
+                                  <p:stCondLst>
+                                    <p:cond delay="0"/>
+                                  </p:stCondLst>
+                                  <p:childTnLst>
+                                    <p:set>
+                                      <p:cBhvr>
+                                        <p:cTn id="31" dur="1" fill="hold">
+                                          <p:stCondLst>
+                                            <p:cond delay="0"/>
+                                          </p:stCondLst>
+                                        </p:cTn>
+                                        <p:tgtEl>
+                                          <p:spTgt spid="11"/>
+                                        </p:tgtEl>
+                                        <p:attrNameLst>
+                                          <p:attrName>style.visibility</p:attrName>
+                                        </p:attrNameLst>
+                                      </p:cBhvr>
+                                      <p:to>
+                                        <p:strVal val="visible"/>
+                                      </p:to>
+                                    </p:set>
+                                    <p:animEffect transition="in" filter="fade">
+                                      <p:cBhvr>
+                                        <p:cTn id="32" dur="500">
+                                          <p:tgtEl>
+                                            <p:spTgt spid="11"/>
                                           </p:tgtEl>
                                         </p:cTn>
                                       </p:cBhvr>
@@ -11081,6 +10954,8 @@
       <p:bldP spid="7" grpId="0" bldLvl="0" animBg="1"/>
       <p:bldP spid="8" grpId="0" bldLvl="0" animBg="1"/>
       <p:bldP spid="9" grpId="0" bldLvl="0" animBg="1"/>
+      <p:bldP spid="10" grpId="0" bldLvl="0" animBg="1"/>
+      <p:bldP spid="11" grpId="0" bldLvl="0" animBg="1"/>
     </p:bldLst>
   </p:timing>
 </p:sld>
@@ -11478,7 +11353,7 @@
                   <a:srgbClr val="0F172A"/>
                 </a:solidFill>
               </a:rPr>
-              <a:t>09  Dashboard &amp; 6 Workflows — </a:t>
+              <a:t>09  Platform Tri-Engine Suite — </a:t>
             </a:r>
             <a:r>
               <a:rPr sz="950">
@@ -11486,7 +11361,7 @@
                   <a:srgbClr val="334155"/>
                 </a:solidFill>
               </a:rPr>
-              <a:t>Live Coverage Cockpit, Waveform Studio &amp; Repair
+              <a:t>VeriSight Debug, Plan Architect &amp; Spec-Driven TestBench
 </a:t>
             </a:r>
           </a:p>
@@ -11877,7 +11752,7 @@
                 </a:solidFill>
                 <a:latin typeface="Arial"/>
               </a:rPr>
-              <a:t>ENTERPRISE INTEGRATION  •  </a:t>
+              <a:t>PRODUCT ROADMAP  •  </a:t>
             </a:r>
             <a:r>
               <a:rPr sz="2100" b="1">
@@ -11886,7 +11761,7 @@
                 </a:solidFill>
                 <a:latin typeface="Arial"/>
               </a:rPr>
-              <a:t>Topic 13: Integration Into Real World Chip Design</a:t>
+              <a:t>Topic 12: Future Scope — The Autonomous Silicon Roadmap</a:t>
             </a:r>
           </a:p>
         </p:txBody>
@@ -11900,7 +11775,7 @@
         <p:spPr>
           <a:xfrm>
             <a:off x="731520" y="1371600"/>
-            <a:ext cx="5486400" cy="4846320"/>
+            <a:ext cx="3429000" cy="4846320"/>
           </a:xfrm>
           <a:prstGeom prst="roundRect">
             <a:avLst/>
@@ -11944,8 +11819,8 @@
         </p:nvSpPr>
         <p:spPr>
           <a:xfrm>
-            <a:off x="914400" y="1508760"/>
-            <a:ext cx="5120640" cy="4572000"/>
+            <a:off x="914400" y="1554480"/>
+            <a:ext cx="3063240" cy="4480560"/>
           </a:xfrm>
           <a:prstGeom prst="rect">
             <a:avLst/>
@@ -11959,89 +11834,39 @@
           <a:lstStyle/>
           <a:p>
             <a:r>
-              <a:rPr sz="1400" b="1">
+              <a:rPr sz="1300" b="1">
                 <a:solidFill>
                   <a:srgbClr val="0B4D32"/>
                 </a:solidFill>
               </a:rPr>
-              <a:t>Day-1 Frictionless CI/CD Deployment
+              <a:t>Phase 1: Present (v2.4)
 </a:t>
             </a:r>
           </a:p>
           <a:p>
             <a:r>
-              <a:rPr b="1" sz="1050">
+              <a:rPr sz="1100" b="1">
                 <a:solidFill>
                   <a:srgbClr val="0F172A"/>
                 </a:solidFill>
               </a:rPr>
-              <a:t>• CI/CD Pipeline Hooks: </a:t>
-            </a:r>
+              <a:t>Production Tri-Engine Architecture
+</a:t>
+            </a:r>
+          </a:p>
+          <a:p>
             <a:r>
               <a:rPr sz="950">
                 <a:solidFill>
                   <a:srgbClr val="334155"/>
                 </a:solidFill>
               </a:rPr>
-              <a:t>Integrates natively into Jenkins, GitLab CI, GitHub Actions via headless CLI.
-</a:t>
-            </a:r>
-          </a:p>
-          <a:p>
-            <a:r>
-              <a:rPr b="1" sz="1050">
-                <a:solidFill>
-                  <a:srgbClr val="0F172A"/>
-                </a:solidFill>
-              </a:rPr>
-              <a:t>• Zero EDA Toolchain Disruption: </a:t>
-            </a:r>
-            <a:r>
-              <a:rPr sz="950">
-                <a:solidFill>
-                  <a:srgbClr val="334155"/>
-                </a:solidFill>
-              </a:rPr>
-              <a:t>Wraps around existing Synopsys, Siemens, and Cadence regression scripts without modifying Makefiles.
-</a:t>
-            </a:r>
-          </a:p>
-          <a:p>
-            <a:r>
-              <a:rPr b="1" sz="1050">
-                <a:solidFill>
-                  <a:srgbClr val="0F172A"/>
-                </a:solidFill>
-              </a:rPr>
-              <a:t>• Standard Format Ingestion: </a:t>
-            </a:r>
-            <a:r>
-              <a:rPr sz="950">
-                <a:solidFill>
-                  <a:srgbClr val="334155"/>
-                </a:solidFill>
-              </a:rPr>
-              <a:t>Parses industry standard formats: SystemVerilog (.sv), VCD, FSDB, UCDB, and JUnit XML.
-</a:t>
-            </a:r>
-          </a:p>
-          <a:p>
-            <a:r>
-              <a:rPr b="1" sz="1050">
-                <a:solidFill>
-                  <a:srgbClr val="0F172A"/>
-                </a:solidFill>
-              </a:rPr>
-              <a:t>• Strict Enterprise Security Boundary: </a:t>
-            </a:r>
-            <a:r>
-              <a:rPr sz="950">
-                <a:solidFill>
-                  <a:srgbClr val="334155"/>
-                </a:solidFill>
-              </a:rPr>
-              <a:t>Air-gapped on-premise execution with local Ollama/vLLM endpoints and complete RTL IP sanitization.
-</a:t>
+              <a:t>• Tri-Engine Suite: Debug, Plan &amp; TestBench
+• Spec-Driven UVM 1.2 Synthesis Agent
+• 9 Formal RCA Decision Rules
+• pyslang IEEE-1800 AST X-Tracer
+• Live Coverage Cockpit &amp; Waveform Studio
+• Zero-Touch Sandbox Auto-Patching</a:t>
             </a:r>
           </a:p>
         </p:txBody>
@@ -12054,8 +11879,8 @@
         </p:nvSpPr>
         <p:spPr>
           <a:xfrm>
-            <a:off x="6400800" y="1371600"/>
-            <a:ext cx="5029200" cy="4846320"/>
+            <a:off x="4343400" y="1371600"/>
+            <a:ext cx="3429000" cy="4846320"/>
           </a:xfrm>
           <a:prstGeom prst="roundRect">
             <a:avLst/>
@@ -12065,7 +11890,7 @@
           </a:solidFill>
           <a:ln w="12700">
             <a:solidFill>
-              <a:srgbClr val="CBD5E1"/>
+              <a:srgbClr val="0284C7"/>
             </a:solidFill>
           </a:ln>
         </p:spPr>
@@ -12091,40 +11916,16 @@
           </a:p>
         </p:txBody>
       </p:sp>
-      <p:pic>
-        <p:nvPicPr>
-          <p:cNvPr id="7" name="Picture 6" descr="screenshot_15_ci_cd_regression.png"/>
-          <p:cNvPicPr>
-            <a:picLocks noChangeAspect="1"/>
-          </p:cNvPicPr>
-          <p:nvPr/>
-        </p:nvPicPr>
-        <p:blipFill>
-          <a:blip r:embed="rId3"/>
-          <a:stretch>
-            <a:fillRect/>
-          </a:stretch>
-        </p:blipFill>
-        <p:spPr>
-          <a:xfrm>
-            <a:off x="6492240" y="1508760"/>
-            <a:ext cx="4846320" cy="3931920"/>
-          </a:xfrm>
-          <a:prstGeom prst="rect">
-            <a:avLst/>
-          </a:prstGeom>
-        </p:spPr>
-      </p:pic>
       <p:sp>
         <p:nvSpPr>
-          <p:cNvPr id="8" name="TextBox 7"/>
+          <p:cNvPr id="7" name="TextBox 6"/>
           <p:cNvSpPr txBox="1"/>
           <p:nvPr/>
         </p:nvSpPr>
         <p:spPr>
           <a:xfrm>
-            <a:off x="6492240" y="5532120"/>
-            <a:ext cx="4846320" cy="548640"/>
+            <a:off x="4526280" y="1554480"/>
+            <a:ext cx="3063240" cy="4480560"/>
           </a:xfrm>
           <a:prstGeom prst="rect">
             <a:avLst/>
@@ -12132,18 +11933,148 @@
           <a:noFill/>
         </p:spPr>
         <p:txBody>
-          <a:bodyPr wrap="none">
+          <a:bodyPr wrap="square">
             <a:spAutoFit/>
           </a:bodyPr>
           <a:lstStyle/>
           <a:p>
             <a:r>
-              <a:rPr sz="950" b="1">
-                <a:solidFill>
-                  <a:srgbClr val="64748B"/>
-                </a:solidFill>
-              </a:rPr>
-              <a:t>Headless CI/CD Nightly Regression Triage Automation</a:t>
+              <a:rPr sz="1300" b="1">
+                <a:solidFill>
+                  <a:srgbClr val="0284C7"/>
+                </a:solidFill>
+              </a:rPr>
+              <a:t>Phase 2: Q1-Q2 2027
+</a:t>
+            </a:r>
+          </a:p>
+          <a:p>
+            <a:r>
+              <a:rPr sz="1100" b="1">
+                <a:solidFill>
+                  <a:srgbClr val="0F172A"/>
+                </a:solidFill>
+              </a:rPr>
+              <a:t>Continuous Regression Intelligence
+</a:t>
+            </a:r>
+          </a:p>
+          <a:p>
+            <a:r>
+              <a:rPr sz="950">
+                <a:solidFill>
+                  <a:srgbClr val="334155"/>
+                </a:solidFill>
+              </a:rPr>
+              <a:t>• Nightly farm log clustering &amp; anomaly grouping
+• Automated test deduplication
+• Bayesian stimulus tuning for coverage holes
+• Cross-project historical defect memory
+• Automated Git Pull Request review comments</a:t>
+            </a:r>
+          </a:p>
+        </p:txBody>
+      </p:sp>
+      <p:sp>
+        <p:nvSpPr>
+          <p:cNvPr id="8" name="Rounded Rectangle 7"/>
+          <p:cNvSpPr/>
+          <p:nvPr/>
+        </p:nvSpPr>
+        <p:spPr>
+          <a:xfrm>
+            <a:off x="7955280" y="1371600"/>
+            <a:ext cx="3429000" cy="4846320"/>
+          </a:xfrm>
+          <a:prstGeom prst="roundRect">
+            <a:avLst/>
+          </a:prstGeom>
+          <a:solidFill>
+            <a:srgbClr val="FFFFFF"/>
+          </a:solidFill>
+          <a:ln w="12700">
+            <a:solidFill>
+              <a:srgbClr val="D97706"/>
+            </a:solidFill>
+          </a:ln>
+        </p:spPr>
+        <p:style>
+          <a:lnRef idx="1">
+            <a:schemeClr val="accent1"/>
+          </a:lnRef>
+          <a:fillRef idx="3">
+            <a:schemeClr val="accent1"/>
+          </a:fillRef>
+          <a:effectRef idx="2">
+            <a:schemeClr val="accent1"/>
+          </a:effectRef>
+          <a:fontRef idx="minor">
+            <a:schemeClr val="lt1"/>
+          </a:fontRef>
+        </p:style>
+        <p:txBody>
+          <a:bodyPr rtlCol="0" anchor="ctr"/>
+          <a:lstStyle/>
+          <a:p>
+            <a:pPr algn="ctr"/>
+          </a:p>
+        </p:txBody>
+      </p:sp>
+      <p:sp>
+        <p:nvSpPr>
+          <p:cNvPr id="9" name="TextBox 8"/>
+          <p:cNvSpPr txBox="1"/>
+          <p:nvPr/>
+        </p:nvSpPr>
+        <p:spPr>
+          <a:xfrm>
+            <a:off x="8138160" y="1554480"/>
+            <a:ext cx="3063240" cy="4480560"/>
+          </a:xfrm>
+          <a:prstGeom prst="rect">
+            <a:avLst/>
+          </a:prstGeom>
+          <a:noFill/>
+        </p:spPr>
+        <p:txBody>
+          <a:bodyPr wrap="square">
+            <a:spAutoFit/>
+          </a:bodyPr>
+          <a:lstStyle/>
+          <a:p>
+            <a:r>
+              <a:rPr sz="1300" b="1">
+                <a:solidFill>
+                  <a:srgbClr val="D97706"/>
+                </a:solidFill>
+              </a:rPr>
+              <a:t>Phase 3: Q3-Q4 2027
+</a:t>
+            </a:r>
+          </a:p>
+          <a:p>
+            <a:r>
+              <a:rPr sz="1100" b="1">
+                <a:solidFill>
+                  <a:srgbClr val="0F172A"/>
+                </a:solidFill>
+              </a:rPr>
+              <a:t>Silicon-to-Software Autonomous Loop
+</a:t>
+            </a:r>
+          </a:p>
+          <a:p>
+            <a:r>
+              <a:rPr sz="950">
+                <a:solidFill>
+                  <a:srgbClr val="334155"/>
+                </a:solidFill>
+              </a:rPr>
+              <a:t>• Post-silicon ATE automated tester link
+• Scan chain fault diagnosis &amp; silicon debug
+• Automated ATPG test vector synthesis
+• Formal mathematical theorem proving
+• ISO 26262 ASIL-D safety lifecycle sign-off</a:t>
             </a:r>
           </a:p>
         </p:txBody>
@@ -12255,13 +12186,13 @@
                     </p:cTn>
                   </p:par>
                   <p:par>
-                    <p:cTn id="20" fill="hold">
+                    <p:cTn id="17" fill="hold">
                       <p:stCondLst>
                         <p:cond delay="indefinite"/>
                       </p:stCondLst>
                       <p:childTnLst>
                         <p:par>
-                          <p:cTn id="21" fill="hold">
+                          <p:cTn id="18" fill="hold">
                             <p:stCondLst>
                               <p:cond delay="0"/>
                             </p:stCondLst>
@@ -12338,15 +12269,33 @@
                                   </p:childTnLst>
                                 </p:cTn>
                               </p:par>
+                            </p:childTnLst>
+                          </p:cTn>
+                        </p:par>
+                      </p:childTnLst>
+                    </p:cTn>
+                  </p:par>
+                  <p:par>
+                    <p:cTn id="25" fill="hold">
+                      <p:stCondLst>
+                        <p:cond delay="indefinite"/>
+                      </p:stCondLst>
+                      <p:childTnLst>
+                        <p:par>
+                          <p:cTn id="26" fill="hold">
+                            <p:stCondLst>
+                              <p:cond delay="0"/>
+                            </p:stCondLst>
+                            <p:childTnLst>
                               <p:par>
-                                <p:cTn id="17" presetID="10" presetClass="entr" presetSubtype="0" fill="hold" grpId="0" nodeType="withEffect">
+                                <p:cTn id="19" presetID="10" presetClass="entr" presetSubtype="0" fill="hold" grpId="0" nodeType="clickEffect">
                                   <p:stCondLst>
                                     <p:cond delay="0"/>
                                   </p:stCondLst>
                                   <p:childTnLst>
                                     <p:set>
                                       <p:cBhvr>
-                                        <p:cTn id="18" dur="1" fill="hold">
+                                        <p:cTn id="20" dur="1" fill="hold">
                                           <p:stCondLst>
                                             <p:cond delay="0"/>
                                           </p:stCondLst>
@@ -12364,9 +12313,45 @@
                                     </p:set>
                                     <p:animEffect transition="in" filter="fade">
                                       <p:cBhvr>
-                                        <p:cTn id="19" dur="500">
+                                        <p:cTn id="21" dur="500">
                                           <p:tgtEl>
                                             <p:spTgt spid="8"/>
+                                          </p:tgtEl>
+                                        </p:cTn>
+                                      </p:cBhvr>
+                                    </p:animEffect>
+                                  </p:childTnLst>
+                                </p:cTn>
+                              </p:par>
+                              <p:par>
+                                <p:cTn id="22" presetID="10" presetClass="entr" presetSubtype="0" fill="hold" grpId="0" nodeType="withEffect">
+                                  <p:stCondLst>
+                                    <p:cond delay="0"/>
+                                  </p:stCondLst>
+                                  <p:childTnLst>
+                                    <p:set>
+                                      <p:cBhvr>
+                                        <p:cTn id="23" dur="1" fill="hold">
+                                          <p:stCondLst>
+                                            <p:cond delay="0"/>
+                                          </p:stCondLst>
+                                        </p:cTn>
+                                        <p:tgtEl>
+                                          <p:spTgt spid="9"/>
+                                        </p:tgtEl>
+                                        <p:attrNameLst>
+                                          <p:attrName>style.visibility</p:attrName>
+                                        </p:attrNameLst>
+                                      </p:cBhvr>
+                                      <p:to>
+                                        <p:strVal val="visible"/>
+                                      </p:to>
+                                    </p:set>
+                                    <p:animEffect transition="in" filter="fade">
+                                      <p:cBhvr>
+                                        <p:cTn id="24" dur="500">
+                                          <p:tgtEl>
+                                            <p:spTgt spid="9"/>
                                           </p:tgtEl>
                                         </p:cTn>
                                       </p:cBhvr>
@@ -12407,6 +12392,7 @@
       <p:bldP spid="6" grpId="0" bldLvl="0" animBg="1"/>
       <p:bldP spid="7" grpId="0" bldLvl="0" animBg="1"/>
       <p:bldP spid="8" grpId="0" bldLvl="0" animBg="1"/>
+      <p:bldP spid="9" grpId="0" bldLvl="0" animBg="1"/>
     </p:bldLst>
   </p:timing>
 </p:sld>
@@ -12475,6 +12461,604 @@
                 </a:solidFill>
                 <a:latin typeface="Arial"/>
               </a:rPr>
+              <a:t>ENTERPRISE INTEGRATION  •  </a:t>
+            </a:r>
+            <a:r>
+              <a:rPr sz="2100" b="1">
+                <a:solidFill>
+                  <a:srgbClr val="0B4D32"/>
+                </a:solidFill>
+                <a:latin typeface="Arial"/>
+              </a:rPr>
+              <a:t>Topic 13: Integration Into Real World Chip Design</a:t>
+            </a:r>
+          </a:p>
+        </p:txBody>
+      </p:sp>
+      <p:sp>
+        <p:nvSpPr>
+          <p:cNvPr id="4" name="Rounded Rectangle 3"/>
+          <p:cNvSpPr/>
+          <p:nvPr/>
+        </p:nvSpPr>
+        <p:spPr>
+          <a:xfrm>
+            <a:off x="731520" y="1371600"/>
+            <a:ext cx="5486400" cy="4846320"/>
+          </a:xfrm>
+          <a:prstGeom prst="roundRect">
+            <a:avLst/>
+          </a:prstGeom>
+          <a:solidFill>
+            <a:srgbClr val="FFFFFF"/>
+          </a:solidFill>
+          <a:ln w="12700">
+            <a:solidFill>
+              <a:srgbClr val="0B4D32"/>
+            </a:solidFill>
+          </a:ln>
+        </p:spPr>
+        <p:style>
+          <a:lnRef idx="1">
+            <a:schemeClr val="accent1"/>
+          </a:lnRef>
+          <a:fillRef idx="3">
+            <a:schemeClr val="accent1"/>
+          </a:fillRef>
+          <a:effectRef idx="2">
+            <a:schemeClr val="accent1"/>
+          </a:effectRef>
+          <a:fontRef idx="minor">
+            <a:schemeClr val="lt1"/>
+          </a:fontRef>
+        </p:style>
+        <p:txBody>
+          <a:bodyPr rtlCol="0" anchor="ctr"/>
+          <a:lstStyle/>
+          <a:p>
+            <a:pPr algn="ctr"/>
+          </a:p>
+        </p:txBody>
+      </p:sp>
+      <p:sp>
+        <p:nvSpPr>
+          <p:cNvPr id="5" name="TextBox 4"/>
+          <p:cNvSpPr txBox="1"/>
+          <p:nvPr/>
+        </p:nvSpPr>
+        <p:spPr>
+          <a:xfrm>
+            <a:off x="914400" y="1508760"/>
+            <a:ext cx="5120640" cy="4572000"/>
+          </a:xfrm>
+          <a:prstGeom prst="rect">
+            <a:avLst/>
+          </a:prstGeom>
+          <a:noFill/>
+        </p:spPr>
+        <p:txBody>
+          <a:bodyPr wrap="square">
+            <a:spAutoFit/>
+          </a:bodyPr>
+          <a:lstStyle/>
+          <a:p>
+            <a:r>
+              <a:rPr sz="1400" b="1">
+                <a:solidFill>
+                  <a:srgbClr val="0B4D32"/>
+                </a:solidFill>
+              </a:rPr>
+              <a:t>Day-1 Frictionless CI/CD Deployment
+</a:t>
+            </a:r>
+          </a:p>
+          <a:p>
+            <a:r>
+              <a:rPr b="1" sz="1050">
+                <a:solidFill>
+                  <a:srgbClr val="0F172A"/>
+                </a:solidFill>
+              </a:rPr>
+              <a:t>• CI/CD Pipeline Hooks: </a:t>
+            </a:r>
+            <a:r>
+              <a:rPr sz="950">
+                <a:solidFill>
+                  <a:srgbClr val="334155"/>
+                </a:solidFill>
+              </a:rPr>
+              <a:t>Integrates natively into Jenkins, GitLab CI, GitHub Actions via headless CLI.
+</a:t>
+            </a:r>
+          </a:p>
+          <a:p>
+            <a:r>
+              <a:rPr b="1" sz="1050">
+                <a:solidFill>
+                  <a:srgbClr val="0F172A"/>
+                </a:solidFill>
+              </a:rPr>
+              <a:t>• Zero EDA Toolchain Disruption: </a:t>
+            </a:r>
+            <a:r>
+              <a:rPr sz="950">
+                <a:solidFill>
+                  <a:srgbClr val="334155"/>
+                </a:solidFill>
+              </a:rPr>
+              <a:t>Wraps around existing Synopsys, Siemens, and Cadence regression scripts without modifying Makefiles.
+</a:t>
+            </a:r>
+          </a:p>
+          <a:p>
+            <a:r>
+              <a:rPr b="1" sz="1050">
+                <a:solidFill>
+                  <a:srgbClr val="0F172A"/>
+                </a:solidFill>
+              </a:rPr>
+              <a:t>• Standard Format Ingestion: </a:t>
+            </a:r>
+            <a:r>
+              <a:rPr sz="950">
+                <a:solidFill>
+                  <a:srgbClr val="334155"/>
+                </a:solidFill>
+              </a:rPr>
+              <a:t>Parses industry standard formats: SystemVerilog (.sv), VCD, FSDB, UCDB, and JUnit XML.
+</a:t>
+            </a:r>
+          </a:p>
+          <a:p>
+            <a:r>
+              <a:rPr b="1" sz="1050">
+                <a:solidFill>
+                  <a:srgbClr val="0F172A"/>
+                </a:solidFill>
+              </a:rPr>
+              <a:t>• Strict Enterprise Security Boundary: </a:t>
+            </a:r>
+            <a:r>
+              <a:rPr sz="950">
+                <a:solidFill>
+                  <a:srgbClr val="334155"/>
+                </a:solidFill>
+              </a:rPr>
+              <a:t>Air-gapped on-premise execution with local Ollama/vLLM endpoints and complete RTL IP sanitization.
+</a:t>
+            </a:r>
+          </a:p>
+        </p:txBody>
+      </p:sp>
+      <p:sp>
+        <p:nvSpPr>
+          <p:cNvPr id="6" name="Rounded Rectangle 5"/>
+          <p:cNvSpPr/>
+          <p:nvPr/>
+        </p:nvSpPr>
+        <p:spPr>
+          <a:xfrm>
+            <a:off x="6400800" y="1371600"/>
+            <a:ext cx="5029200" cy="4846320"/>
+          </a:xfrm>
+          <a:prstGeom prst="roundRect">
+            <a:avLst/>
+          </a:prstGeom>
+          <a:solidFill>
+            <a:srgbClr val="FFFFFF"/>
+          </a:solidFill>
+          <a:ln w="12700">
+            <a:solidFill>
+              <a:srgbClr val="CBD5E1"/>
+            </a:solidFill>
+          </a:ln>
+        </p:spPr>
+        <p:style>
+          <a:lnRef idx="1">
+            <a:schemeClr val="accent1"/>
+          </a:lnRef>
+          <a:fillRef idx="3">
+            <a:schemeClr val="accent1"/>
+          </a:fillRef>
+          <a:effectRef idx="2">
+            <a:schemeClr val="accent1"/>
+          </a:effectRef>
+          <a:fontRef idx="minor">
+            <a:schemeClr val="lt1"/>
+          </a:fontRef>
+        </p:style>
+        <p:txBody>
+          <a:bodyPr rtlCol="0" anchor="ctr"/>
+          <a:lstStyle/>
+          <a:p>
+            <a:pPr algn="ctr"/>
+          </a:p>
+        </p:txBody>
+      </p:sp>
+      <p:pic>
+        <p:nvPicPr>
+          <p:cNvPr id="7" name="Picture 6" descr="screenshot_15_ci_cd_regression.png"/>
+          <p:cNvPicPr>
+            <a:picLocks noChangeAspect="1"/>
+          </p:cNvPicPr>
+          <p:nvPr/>
+        </p:nvPicPr>
+        <p:blipFill>
+          <a:blip r:embed="rId3"/>
+          <a:stretch>
+            <a:fillRect/>
+          </a:stretch>
+        </p:blipFill>
+        <p:spPr>
+          <a:xfrm>
+            <a:off x="6492240" y="1508760"/>
+            <a:ext cx="4846320" cy="3931920"/>
+          </a:xfrm>
+          <a:prstGeom prst="rect">
+            <a:avLst/>
+          </a:prstGeom>
+        </p:spPr>
+      </p:pic>
+      <p:sp>
+        <p:nvSpPr>
+          <p:cNvPr id="8" name="TextBox 7"/>
+          <p:cNvSpPr txBox="1"/>
+          <p:nvPr/>
+        </p:nvSpPr>
+        <p:spPr>
+          <a:xfrm>
+            <a:off x="6492240" y="5532120"/>
+            <a:ext cx="4846320" cy="548640"/>
+          </a:xfrm>
+          <a:prstGeom prst="rect">
+            <a:avLst/>
+          </a:prstGeom>
+          <a:noFill/>
+        </p:spPr>
+        <p:txBody>
+          <a:bodyPr wrap="none">
+            <a:spAutoFit/>
+          </a:bodyPr>
+          <a:lstStyle/>
+          <a:p>
+            <a:r>
+              <a:rPr sz="950" b="1">
+                <a:solidFill>
+                  <a:srgbClr val="64748B"/>
+                </a:solidFill>
+              </a:rPr>
+              <a:t>Headless CI/CD Nightly Regression Triage Automation</a:t>
+            </a:r>
+          </a:p>
+        </p:txBody>
+      </p:sp>
+    </p:spTree>
+  </p:cSld>
+  <p:clrMapOvr>
+    <a:masterClrMapping/>
+  </p:clrMapOvr>
+  <p:transition>
+    <p:fade/>
+  </p:transition>
+  <p:timing>
+    <p:tnLst>
+      <p:par>
+        <p:cTn id="1" dur="indefinite" restart="never" nodeType="tmRoot">
+          <p:childTnLst>
+            <p:seq concurrent="1" nextAc="seek">
+              <p:cTn id="2" dur="indefinite" nodeType="mainSeq">
+                <p:childTnLst>
+                  <p:par>
+                    <p:cTn id="9" fill="hold">
+                      <p:stCondLst>
+                        <p:cond delay="indefinite"/>
+                      </p:stCondLst>
+                      <p:childTnLst>
+                        <p:par>
+                          <p:cTn id="10" fill="hold">
+                            <p:stCondLst>
+                              <p:cond delay="0"/>
+                            </p:stCondLst>
+                            <p:childTnLst>
+                              <p:par>
+                                <p:cTn id="3" presetID="10" presetClass="entr" presetSubtype="0" fill="hold" grpId="0" nodeType="clickEffect">
+                                  <p:stCondLst>
+                                    <p:cond delay="0"/>
+                                  </p:stCondLst>
+                                  <p:childTnLst>
+                                    <p:set>
+                                      <p:cBhvr>
+                                        <p:cTn id="4" dur="1" fill="hold">
+                                          <p:stCondLst>
+                                            <p:cond delay="0"/>
+                                          </p:stCondLst>
+                                        </p:cTn>
+                                        <p:tgtEl>
+                                          <p:spTgt spid="4"/>
+                                        </p:tgtEl>
+                                        <p:attrNameLst>
+                                          <p:attrName>style.visibility</p:attrName>
+                                        </p:attrNameLst>
+                                      </p:cBhvr>
+                                      <p:to>
+                                        <p:strVal val="visible"/>
+                                      </p:to>
+                                    </p:set>
+                                    <p:animEffect transition="in" filter="fade">
+                                      <p:cBhvr>
+                                        <p:cTn id="5" dur="500">
+                                          <p:tgtEl>
+                                            <p:spTgt spid="4"/>
+                                          </p:tgtEl>
+                                        </p:cTn>
+                                      </p:cBhvr>
+                                    </p:animEffect>
+                                  </p:childTnLst>
+                                </p:cTn>
+                              </p:par>
+                              <p:par>
+                                <p:cTn id="6" presetID="10" presetClass="entr" presetSubtype="0" fill="hold" grpId="0" nodeType="withEffect">
+                                  <p:stCondLst>
+                                    <p:cond delay="0"/>
+                                  </p:stCondLst>
+                                  <p:childTnLst>
+                                    <p:set>
+                                      <p:cBhvr>
+                                        <p:cTn id="7" dur="1" fill="hold">
+                                          <p:stCondLst>
+                                            <p:cond delay="0"/>
+                                          </p:stCondLst>
+                                        </p:cTn>
+                                        <p:tgtEl>
+                                          <p:spTgt spid="5"/>
+                                        </p:tgtEl>
+                                        <p:attrNameLst>
+                                          <p:attrName>style.visibility</p:attrName>
+                                        </p:attrNameLst>
+                                      </p:cBhvr>
+                                      <p:to>
+                                        <p:strVal val="visible"/>
+                                      </p:to>
+                                    </p:set>
+                                    <p:animEffect transition="in" filter="fade">
+                                      <p:cBhvr>
+                                        <p:cTn id="8" dur="500">
+                                          <p:tgtEl>
+                                            <p:spTgt spid="5"/>
+                                          </p:tgtEl>
+                                        </p:cTn>
+                                      </p:cBhvr>
+                                    </p:animEffect>
+                                  </p:childTnLst>
+                                </p:cTn>
+                              </p:par>
+                            </p:childTnLst>
+                          </p:cTn>
+                        </p:par>
+                      </p:childTnLst>
+                    </p:cTn>
+                  </p:par>
+                  <p:par>
+                    <p:cTn id="20" fill="hold">
+                      <p:stCondLst>
+                        <p:cond delay="indefinite"/>
+                      </p:stCondLst>
+                      <p:childTnLst>
+                        <p:par>
+                          <p:cTn id="21" fill="hold">
+                            <p:stCondLst>
+                              <p:cond delay="0"/>
+                            </p:stCondLst>
+                            <p:childTnLst>
+                              <p:par>
+                                <p:cTn id="11" presetID="10" presetClass="entr" presetSubtype="0" fill="hold" grpId="0" nodeType="clickEffect">
+                                  <p:stCondLst>
+                                    <p:cond delay="0"/>
+                                  </p:stCondLst>
+                                  <p:childTnLst>
+                                    <p:set>
+                                      <p:cBhvr>
+                                        <p:cTn id="12" dur="1" fill="hold">
+                                          <p:stCondLst>
+                                            <p:cond delay="0"/>
+                                          </p:stCondLst>
+                                        </p:cTn>
+                                        <p:tgtEl>
+                                          <p:spTgt spid="6"/>
+                                        </p:tgtEl>
+                                        <p:attrNameLst>
+                                          <p:attrName>style.visibility</p:attrName>
+                                        </p:attrNameLst>
+                                      </p:cBhvr>
+                                      <p:to>
+                                        <p:strVal val="visible"/>
+                                      </p:to>
+                                    </p:set>
+                                    <p:animEffect transition="in" filter="fade">
+                                      <p:cBhvr>
+                                        <p:cTn id="13" dur="500">
+                                          <p:tgtEl>
+                                            <p:spTgt spid="6"/>
+                                          </p:tgtEl>
+                                        </p:cTn>
+                                      </p:cBhvr>
+                                    </p:animEffect>
+                                  </p:childTnLst>
+                                </p:cTn>
+                              </p:par>
+                              <p:par>
+                                <p:cTn id="14" presetID="10" presetClass="entr" presetSubtype="0" fill="hold" grpId="0" nodeType="withEffect">
+                                  <p:stCondLst>
+                                    <p:cond delay="0"/>
+                                  </p:stCondLst>
+                                  <p:childTnLst>
+                                    <p:set>
+                                      <p:cBhvr>
+                                        <p:cTn id="15" dur="1" fill="hold">
+                                          <p:stCondLst>
+                                            <p:cond delay="0"/>
+                                          </p:stCondLst>
+                                        </p:cTn>
+                                        <p:tgtEl>
+                                          <p:spTgt spid="7"/>
+                                        </p:tgtEl>
+                                        <p:attrNameLst>
+                                          <p:attrName>style.visibility</p:attrName>
+                                        </p:attrNameLst>
+                                      </p:cBhvr>
+                                      <p:to>
+                                        <p:strVal val="visible"/>
+                                      </p:to>
+                                    </p:set>
+                                    <p:animEffect transition="in" filter="fade">
+                                      <p:cBhvr>
+                                        <p:cTn id="16" dur="500">
+                                          <p:tgtEl>
+                                            <p:spTgt spid="7"/>
+                                          </p:tgtEl>
+                                        </p:cTn>
+                                      </p:cBhvr>
+                                    </p:animEffect>
+                                  </p:childTnLst>
+                                </p:cTn>
+                              </p:par>
+                              <p:par>
+                                <p:cTn id="17" presetID="10" presetClass="entr" presetSubtype="0" fill="hold" grpId="0" nodeType="withEffect">
+                                  <p:stCondLst>
+                                    <p:cond delay="0"/>
+                                  </p:stCondLst>
+                                  <p:childTnLst>
+                                    <p:set>
+                                      <p:cBhvr>
+                                        <p:cTn id="18" dur="1" fill="hold">
+                                          <p:stCondLst>
+                                            <p:cond delay="0"/>
+                                          </p:stCondLst>
+                                        </p:cTn>
+                                        <p:tgtEl>
+                                          <p:spTgt spid="8"/>
+                                        </p:tgtEl>
+                                        <p:attrNameLst>
+                                          <p:attrName>style.visibility</p:attrName>
+                                        </p:attrNameLst>
+                                      </p:cBhvr>
+                                      <p:to>
+                                        <p:strVal val="visible"/>
+                                      </p:to>
+                                    </p:set>
+                                    <p:animEffect transition="in" filter="fade">
+                                      <p:cBhvr>
+                                        <p:cTn id="19" dur="500">
+                                          <p:tgtEl>
+                                            <p:spTgt spid="8"/>
+                                          </p:tgtEl>
+                                        </p:cTn>
+                                      </p:cBhvr>
+                                    </p:animEffect>
+                                  </p:childTnLst>
+                                </p:cTn>
+                              </p:par>
+                            </p:childTnLst>
+                          </p:cTn>
+                        </p:par>
+                      </p:childTnLst>
+                    </p:cTn>
+                  </p:par>
+                </p:childTnLst>
+              </p:cTn>
+              <p:prevCondLst>
+                <p:cond evt="onPrev" delay="0">
+                  <p:tgtEl>
+                    <p:sldTgt/>
+                  </p:tgtEl>
+                </p:cond>
+              </p:prevCondLst>
+              <p:nextCondLst>
+                <p:cond evt="onNext" delay="0">
+                  <p:tgtEl>
+                    <p:sldTgt/>
+                  </p:tgtEl>
+                </p:cond>
+              </p:nextCondLst>
+            </p:seq>
+          </p:childTnLst>
+        </p:cTn>
+      </p:par>
+    </p:tnLst>
+    <p:bldLst>
+      <p:bldP spid="4" grpId="0" bldLvl="0" animBg="1"/>
+      <p:bldP spid="5" grpId="0" bldLvl="0" animBg="1"/>
+      <p:bldP spid="6" grpId="0" bldLvl="0" animBg="1"/>
+      <p:bldP spid="7" grpId="0" bldLvl="0" animBg="1"/>
+      <p:bldP spid="8" grpId="0" bldLvl="0" animBg="1"/>
+    </p:bldLst>
+  </p:timing>
+</p:sld>
+</file>
+
+<file path=ppt/slides/slide22.xml><?xml version="1.0" encoding="utf-8"?>
+<p:sld xmlns:a="http://schemas.openxmlformats.org/drawingml/2006/main" xmlns:p="http://schemas.openxmlformats.org/presentationml/2006/main" xmlns:r="http://schemas.openxmlformats.org/officeDocument/2006/relationships">
+  <p:cSld>
+    <p:spTree>
+      <p:nvGrpSpPr>
+        <p:cNvPr id="1" name=""/>
+        <p:cNvGrpSpPr/>
+        <p:nvPr/>
+      </p:nvGrpSpPr>
+      <p:grpSpPr/>
+      <p:pic>
+        <p:nvPicPr>
+          <p:cNvPr id="2" name="Picture 1" descr="template_slide.png"/>
+          <p:cNvPicPr>
+            <a:picLocks noChangeAspect="1"/>
+          </p:cNvPicPr>
+          <p:nvPr/>
+        </p:nvPicPr>
+        <p:blipFill>
+          <a:blip r:embed="rId2"/>
+          <a:stretch>
+            <a:fillRect/>
+          </a:stretch>
+        </p:blipFill>
+        <p:spPr>
+          <a:xfrm>
+            <a:off x="0" y="0"/>
+            <a:ext cx="12191695" cy="6858000"/>
+          </a:xfrm>
+          <a:prstGeom prst="rect">
+            <a:avLst/>
+          </a:prstGeom>
+        </p:spPr>
+      </p:pic>
+      <p:sp>
+        <p:nvSpPr>
+          <p:cNvPr id="3" name="TextBox 2"/>
+          <p:cNvSpPr txBox="1"/>
+          <p:nvPr/>
+        </p:nvSpPr>
+        <p:spPr>
+          <a:xfrm>
+            <a:off x="731520" y="594360"/>
+            <a:ext cx="10698480" cy="777240"/>
+          </a:xfrm>
+          <a:prstGeom prst="rect">
+            <a:avLst/>
+          </a:prstGeom>
+          <a:noFill/>
+        </p:spPr>
+        <p:txBody>
+          <a:bodyPr wrap="square" lIns="0" tIns="0" rIns="0" bIns="0">
+            <a:spAutoFit/>
+          </a:bodyPr>
+          <a:lstStyle/>
+          <a:p>
+            <a:r>
+              <a:rPr sz="1000" b="1">
+                <a:solidFill>
+                  <a:srgbClr val="0284C7"/>
+                </a:solidFill>
+                <a:latin typeface="Arial"/>
+              </a:rPr>
               <a:t>VERIFICATION STANDARDS  •  </a:t>
             </a:r>
             <a:r>
@@ -12664,7 +13248,7 @@
                 </a:solidFill>
               </a:rPr>
               <a:t>• Full support for IEEE 1800-2023 SystemVerilog language constructs, packages, and interfaces via pyslang.
-• Native understanding of UVM TLM 2.0 communication ports, sequence items, drivers, and scoreboards.</a:t>
+• Synthesis of complete UVM 1.2 VIP environments: sequence items, sequencers, drivers, monitors, golden reference models, and scoreboards.</a:t>
             </a:r>
           </a:p>
         </p:txBody>
@@ -13260,7 +13844,7 @@
 </p:sld>
 </file>
 
-<file path=ppt/slides/slide22.xml><?xml version="1.0" encoding="utf-8"?>
+<file path=ppt/slides/slide23.xml><?xml version="1.0" encoding="utf-8"?>
 <p:sld xmlns:a="http://schemas.openxmlformats.org/drawingml/2006/main" xmlns:p="http://schemas.openxmlformats.org/presentationml/2006/main" xmlns:r="http://schemas.openxmlformats.org/officeDocument/2006/relationships">
   <p:cSld>
     <p:spTree>
@@ -13721,7 +14305,7 @@
                   <a:srgbClr val="334155"/>
                 </a:solidFill>
               </a:rPr>
-              <a:t>Autonomous silicon verification &amp; failure debugging copilot designed for digital ASIC &amp; SoC design.
+              <a:t>Autonomous silicon verification, testbench synthesis &amp; failure debugging copilot designed for digital ASIC &amp; SoC design.
 </a:t>
             </a:r>
           </a:p>
@@ -13759,7 +14343,7 @@
                   <a:srgbClr val="334155"/>
                 </a:solidFill>
               </a:rPr>
-              <a:t>Deep closed-loop integration: Directly invokes EDA simulators (VCS, Questa, Verilator) and parses waveforms.
+              <a:t>Tri-Engine Architecture: Diagnostic Debug, Verification Plan Synthesis, and Spec-Driven UVM 1.2 Testbench Generation.
 </a:t>
             </a:r>
           </a:p>
@@ -13849,7 +14433,7 @@
                   <a:srgbClr val="0F172A"/>
                 </a:solidFill>
               </a:rPr>
-              <a:t>• Autonomous Test Plan Synthesis: </a:t>
+              <a:t>• Spec-Driven UVM Synthesis: </a:t>
             </a:r>
             <a:r>
               <a:rPr sz="950">
@@ -13857,7 +14441,7 @@
                   <a:srgbClr val="334155"/>
                 </a:solidFill>
               </a:rPr>
-              <a:t>Extracts features, test sequences, covergroups, and SVA assertions directly from specs.</a:t>
+              <a:t>Synthesizes 14-component UVM 1.2 VIP suites with specification-grounded golden reference models.</a:t>
             </a:r>
           </a:p>
           <a:p>
@@ -13867,7 +14451,7 @@
                   <a:srgbClr val="0F172A"/>
                 </a:solidFill>
               </a:rPr>
-              <a:t>• Closed-Loop Simulation: </a:t>
+              <a:t>• Autonomous Verification Plan: </a:t>
             </a:r>
             <a:r>
               <a:rPr sz="950">
@@ -13875,7 +14459,7 @@
                   <a:srgbClr val="334155"/>
                 </a:solidFill>
               </a:rPr>
-              <a:t>Simulates RTL and testbench, intercepts errors, dumps VCD traces, and auto-triggers triage.</a:t>
+              <a:t>Extracts 50+ testcases across 8 categories, 90+ coverage points, and 30+ SVA assertions from specs.</a:t>
             </a:r>
           </a:p>
           <a:p>
@@ -14013,7 +14597,7 @@
                   <a:srgbClr val="64748B"/>
                 </a:solidFill>
               </a:rPr>
-              <a:t>VeriSight Guided CLI Launcher with 6 Autonomous Workflows</a:t>
+              <a:t>VeriSight Guided CLI Launcher with Tri-Engine Architecture</a:t>
             </a:r>
           </a:p>
         </p:txBody>

</xml_diff>